<commit_message>
Tableau up and running. Working on Dashboard
</commit_message>
<xml_diff>
--- a/Capstone Presentation.pptx
+++ b/Capstone Presentation.pptx
@@ -16,6 +16,7 @@
     <p:sldId id="258" r:id="rId10"/>
     <p:sldId id="257" r:id="rId11"/>
     <p:sldId id="266" r:id="rId12"/>
+    <p:sldId id="267" r:id="rId13"/>
   </p:sldIdLst>
   <p:sldSz cx="12192000" cy="6858000"/>
   <p:notesSz cx="6858000" cy="9144000"/>
@@ -271,7 +272,7 @@
           <a:p>
             <a:fld id="{605A2A49-CCDC-4D72-BC24-98430E0D28A5}" type="datetimeFigureOut">
               <a:rPr lang="de-AT" smtClean="0"/>
-              <a:t>23.09.2025</a:t>
+              <a:t>15.10.2025</a:t>
             </a:fld>
             <a:endParaRPr lang="de-AT"/>
           </a:p>
@@ -331,6 +332,47 @@
           </a:p>
         </p:txBody>
       </p:sp>
+      <p:cxnSp>
+        <p:nvCxnSpPr>
+          <p:cNvPr id="12" name="Gerader Verbinder 11">
+            <a:extLst>
+              <a:ext uri="{FF2B5EF4-FFF2-40B4-BE49-F238E27FC236}">
+                <a16:creationId xmlns:a16="http://schemas.microsoft.com/office/drawing/2014/main" id="{3E4FB264-EF43-2341-7F53-C2FDD20872EB}"/>
+              </a:ext>
+            </a:extLst>
+          </p:cNvPr>
+          <p:cNvCxnSpPr/>
+          <p:nvPr userDrawn="1"/>
+        </p:nvCxnSpPr>
+        <p:spPr>
+          <a:xfrm>
+            <a:off x="0" y="1431636"/>
+            <a:ext cx="12192000" cy="0"/>
+          </a:xfrm>
+          <a:prstGeom prst="line">
+            <a:avLst/>
+          </a:prstGeom>
+          <a:ln w="50800">
+            <a:solidFill>
+              <a:srgbClr val="5A9E6F"/>
+            </a:solidFill>
+          </a:ln>
+        </p:spPr>
+        <p:style>
+          <a:lnRef idx="2">
+            <a:schemeClr val="accent1"/>
+          </a:lnRef>
+          <a:fillRef idx="0">
+            <a:schemeClr val="accent1"/>
+          </a:fillRef>
+          <a:effectRef idx="1">
+            <a:schemeClr val="accent1"/>
+          </a:effectRef>
+          <a:fontRef idx="minor">
+            <a:schemeClr val="tx1"/>
+          </a:fontRef>
+        </p:style>
+      </p:cxnSp>
     </p:spTree>
     <p:extLst>
       <p:ext uri="{BB962C8B-B14F-4D97-AF65-F5344CB8AC3E}">
@@ -471,7 +513,7 @@
           <a:p>
             <a:fld id="{605A2A49-CCDC-4D72-BC24-98430E0D28A5}" type="datetimeFigureOut">
               <a:rPr lang="de-AT" smtClean="0"/>
-              <a:t>23.09.2025</a:t>
+              <a:t>15.10.2025</a:t>
             </a:fld>
             <a:endParaRPr lang="de-AT"/>
           </a:p>
@@ -681,7 +723,7 @@
           <a:p>
             <a:fld id="{605A2A49-CCDC-4D72-BC24-98430E0D28A5}" type="datetimeFigureOut">
               <a:rPr lang="de-AT" smtClean="0"/>
-              <a:t>23.09.2025</a:t>
+              <a:t>15.10.2025</a:t>
             </a:fld>
             <a:endParaRPr lang="de-AT"/>
           </a:p>
@@ -881,7 +923,7 @@
           <a:p>
             <a:fld id="{605A2A49-CCDC-4D72-BC24-98430E0D28A5}" type="datetimeFigureOut">
               <a:rPr lang="de-AT" smtClean="0"/>
-              <a:t>23.09.2025</a:t>
+              <a:t>15.10.2025</a:t>
             </a:fld>
             <a:endParaRPr lang="de-AT"/>
           </a:p>
@@ -1157,7 +1199,7 @@
           <a:p>
             <a:fld id="{605A2A49-CCDC-4D72-BC24-98430E0D28A5}" type="datetimeFigureOut">
               <a:rPr lang="de-AT" smtClean="0"/>
-              <a:t>23.09.2025</a:t>
+              <a:t>15.10.2025</a:t>
             </a:fld>
             <a:endParaRPr lang="de-AT"/>
           </a:p>
@@ -1425,7 +1467,7 @@
           <a:p>
             <a:fld id="{605A2A49-CCDC-4D72-BC24-98430E0D28A5}" type="datetimeFigureOut">
               <a:rPr lang="de-AT" smtClean="0"/>
-              <a:t>23.09.2025</a:t>
+              <a:t>15.10.2025</a:t>
             </a:fld>
             <a:endParaRPr lang="de-AT"/>
           </a:p>
@@ -1840,7 +1882,7 @@
           <a:p>
             <a:fld id="{605A2A49-CCDC-4D72-BC24-98430E0D28A5}" type="datetimeFigureOut">
               <a:rPr lang="de-AT" smtClean="0"/>
-              <a:t>23.09.2025</a:t>
+              <a:t>15.10.2025</a:t>
             </a:fld>
             <a:endParaRPr lang="de-AT"/>
           </a:p>
@@ -1982,7 +2024,7 @@
           <a:p>
             <a:fld id="{605A2A49-CCDC-4D72-BC24-98430E0D28A5}" type="datetimeFigureOut">
               <a:rPr lang="de-AT" smtClean="0"/>
-              <a:t>23.09.2025</a:t>
+              <a:t>15.10.2025</a:t>
             </a:fld>
             <a:endParaRPr lang="de-AT"/>
           </a:p>
@@ -2095,7 +2137,7 @@
           <a:p>
             <a:fld id="{605A2A49-CCDC-4D72-BC24-98430E0D28A5}" type="datetimeFigureOut">
               <a:rPr lang="de-AT" smtClean="0"/>
-              <a:t>23.09.2025</a:t>
+              <a:t>15.10.2025</a:t>
             </a:fld>
             <a:endParaRPr lang="de-AT"/>
           </a:p>
@@ -2408,7 +2450,7 @@
           <a:p>
             <a:fld id="{605A2A49-CCDC-4D72-BC24-98430E0D28A5}" type="datetimeFigureOut">
               <a:rPr lang="de-AT" smtClean="0"/>
-              <a:t>23.09.2025</a:t>
+              <a:t>15.10.2025</a:t>
             </a:fld>
             <a:endParaRPr lang="de-AT"/>
           </a:p>
@@ -2697,7 +2739,7 @@
           <a:p>
             <a:fld id="{605A2A49-CCDC-4D72-BC24-98430E0D28A5}" type="datetimeFigureOut">
               <a:rPr lang="de-AT" smtClean="0"/>
-              <a:t>23.09.2025</a:t>
+              <a:t>15.10.2025</a:t>
             </a:fld>
             <a:endParaRPr lang="de-AT"/>
           </a:p>
@@ -2774,9 +2816,12 @@
 <p:sldMaster xmlns:a="http://schemas.openxmlformats.org/drawingml/2006/main" xmlns:r="http://schemas.openxmlformats.org/officeDocument/2006/relationships" xmlns:p="http://schemas.openxmlformats.org/presentationml/2006/main">
   <p:cSld>
     <p:bg>
-      <p:bgRef idx="1001">
-        <a:schemeClr val="bg1"/>
-      </p:bgRef>
+      <p:bgPr>
+        <a:solidFill>
+          <a:srgbClr val="2C5F7C"/>
+        </a:solidFill>
+        <a:effectLst/>
+      </p:bgPr>
     </p:bg>
     <p:spTree>
       <p:nvGrpSpPr>
@@ -2824,10 +2869,10 @@
           <a:lstStyle/>
           <a:p>
             <a:r>
-              <a:rPr lang="de-DE"/>
+              <a:rPr lang="de-DE" dirty="0"/>
               <a:t>Mastertitelformat bearbeiten</a:t>
             </a:r>
-            <a:endParaRPr lang="de-AT"/>
+            <a:endParaRPr lang="de-AT" dirty="0"/>
           </a:p>
         </p:txBody>
       </p:sp>
@@ -2864,38 +2909,38 @@
           <a:p>
             <a:pPr lvl="0"/>
             <a:r>
-              <a:rPr lang="de-DE"/>
+              <a:rPr lang="de-DE" dirty="0"/>
               <a:t>Mastertextformat bearbeiten</a:t>
             </a:r>
           </a:p>
           <a:p>
             <a:pPr lvl="1"/>
             <a:r>
-              <a:rPr lang="de-DE"/>
+              <a:rPr lang="de-DE" dirty="0"/>
               <a:t>Zweite Ebene</a:t>
             </a:r>
           </a:p>
           <a:p>
             <a:pPr lvl="2"/>
             <a:r>
-              <a:rPr lang="de-DE"/>
+              <a:rPr lang="de-DE" dirty="0"/>
               <a:t>Dritte Ebene</a:t>
             </a:r>
           </a:p>
           <a:p>
             <a:pPr lvl="3"/>
             <a:r>
-              <a:rPr lang="de-DE"/>
+              <a:rPr lang="de-DE" dirty="0"/>
               <a:t>Vierte Ebene</a:t>
             </a:r>
           </a:p>
           <a:p>
             <a:pPr lvl="4"/>
             <a:r>
-              <a:rPr lang="de-DE"/>
+              <a:rPr lang="de-DE" dirty="0"/>
               <a:t>Fünfte Ebene</a:t>
             </a:r>
-            <a:endParaRPr lang="de-AT"/>
+            <a:endParaRPr lang="de-AT" dirty="0"/>
           </a:p>
         </p:txBody>
       </p:sp>
@@ -2940,7 +2985,7 @@
           <a:p>
             <a:fld id="{605A2A49-CCDC-4D72-BC24-98430E0D28A5}" type="datetimeFigureOut">
               <a:rPr lang="de-AT" smtClean="0"/>
-              <a:t>23.09.2025</a:t>
+              <a:t>15.10.2025</a:t>
             </a:fld>
             <a:endParaRPr lang="de-AT"/>
           </a:p>
@@ -3036,6 +3081,42 @@
           </a:p>
         </p:txBody>
       </p:sp>
+      <p:cxnSp>
+        <p:nvCxnSpPr>
+          <p:cNvPr id="8" name="Gerader Verbinder 7">
+            <a:extLst>
+              <a:ext uri="{FF2B5EF4-FFF2-40B4-BE49-F238E27FC236}">
+                <a16:creationId xmlns:a16="http://schemas.microsoft.com/office/drawing/2014/main" id="{B18A94E7-C96A-A9ED-D36C-06949306C341}"/>
+              </a:ext>
+            </a:extLst>
+          </p:cNvPr>
+          <p:cNvCxnSpPr/>
+          <p:nvPr userDrawn="1"/>
+        </p:nvCxnSpPr>
+        <p:spPr>
+          <a:xfrm flipV="1">
+            <a:off x="0" y="1219200"/>
+            <a:ext cx="7638473" cy="212436"/>
+          </a:xfrm>
+          <a:prstGeom prst="line">
+            <a:avLst/>
+          </a:prstGeom>
+        </p:spPr>
+        <p:style>
+          <a:lnRef idx="2">
+            <a:schemeClr val="accent1"/>
+          </a:lnRef>
+          <a:fillRef idx="0">
+            <a:schemeClr val="accent1"/>
+          </a:fillRef>
+          <a:effectRef idx="1">
+            <a:schemeClr val="accent1"/>
+          </a:effectRef>
+          <a:fontRef idx="minor">
+            <a:schemeClr val="tx1"/>
+          </a:fontRef>
+        </p:style>
+      </p:cxnSp>
     </p:spTree>
     <p:extLst>
       <p:ext uri="{BB962C8B-B14F-4D97-AF65-F5344CB8AC3E}">
@@ -3069,7 +3150,7 @@
         <a:buNone/>
         <a:defRPr sz="4400" kern="1200">
           <a:solidFill>
-            <a:schemeClr val="tx1"/>
+            <a:srgbClr val="F5F6FA"/>
           </a:solidFill>
           <a:latin typeface="+mj-lt"/>
           <a:ea typeface="+mj-ea"/>
@@ -3089,7 +3170,7 @@
         <a:buChar char="•"/>
         <a:defRPr sz="2800" kern="1200">
           <a:solidFill>
-            <a:schemeClr val="tx1"/>
+            <a:srgbClr val="F5F6FA"/>
           </a:solidFill>
           <a:latin typeface="+mn-lt"/>
           <a:ea typeface="+mn-ea"/>
@@ -3107,7 +3188,7 @@
         <a:buChar char="•"/>
         <a:defRPr sz="2400" kern="1200">
           <a:solidFill>
-            <a:schemeClr val="tx1"/>
+            <a:srgbClr val="F5F6FA"/>
           </a:solidFill>
           <a:latin typeface="+mn-lt"/>
           <a:ea typeface="+mn-ea"/>
@@ -3125,7 +3206,7 @@
         <a:buChar char="•"/>
         <a:defRPr sz="2000" kern="1200">
           <a:solidFill>
-            <a:schemeClr val="tx1"/>
+            <a:srgbClr val="F5F6FA"/>
           </a:solidFill>
           <a:latin typeface="+mn-lt"/>
           <a:ea typeface="+mn-ea"/>
@@ -3143,7 +3224,7 @@
         <a:buChar char="•"/>
         <a:defRPr sz="1800" kern="1200">
           <a:solidFill>
-            <a:schemeClr val="tx1"/>
+            <a:srgbClr val="F5F6FA"/>
           </a:solidFill>
           <a:latin typeface="+mn-lt"/>
           <a:ea typeface="+mn-ea"/>
@@ -3161,7 +3242,7 @@
         <a:buChar char="•"/>
         <a:defRPr sz="1800" kern="1200">
           <a:solidFill>
-            <a:schemeClr val="tx1"/>
+            <a:srgbClr val="F5F6FA"/>
           </a:solidFill>
           <a:latin typeface="+mn-lt"/>
           <a:ea typeface="+mn-ea"/>
@@ -3721,6 +3802,1729 @@
           <p:cNvGraphicFramePr>
             <a:graphicFrameLocks noGrp="1"/>
           </p:cNvGraphicFramePr>
+          <p:nvPr>
+            <p:extLst>
+              <p:ext uri="{D42A27DB-BD31-4B8C-83A1-F6EECF244321}">
+                <p14:modId xmlns:p14="http://schemas.microsoft.com/office/powerpoint/2010/main" val="110832792"/>
+              </p:ext>
+            </p:extLst>
+          </p:nvPr>
+        </p:nvGraphicFramePr>
+        <p:xfrm>
+          <a:off x="2104845" y="2377440"/>
+          <a:ext cx="8660921" cy="2194560"/>
+        </p:xfrm>
+        <a:graphic>
+          <a:graphicData uri="http://schemas.openxmlformats.org/drawingml/2006/table">
+            <a:tbl>
+              <a:tblPr/>
+              <a:tblGrid>
+                <a:gridCol w="4045789">
+                  <a:extLst>
+                    <a:ext uri="{9D8B030D-6E8A-4147-A177-3AD203B41FA5}">
+                      <a16:colId xmlns:a16="http://schemas.microsoft.com/office/drawing/2014/main" val="2665329781"/>
+                    </a:ext>
+                  </a:extLst>
+                </a:gridCol>
+                <a:gridCol w="4615132">
+                  <a:extLst>
+                    <a:ext uri="{9D8B030D-6E8A-4147-A177-3AD203B41FA5}">
+                      <a16:colId xmlns:a16="http://schemas.microsoft.com/office/drawing/2014/main" val="2614460147"/>
+                    </a:ext>
+                  </a:extLst>
+                </a:gridCol>
+              </a:tblGrid>
+              <a:tr h="54709">
+                <a:tc>
+                  <a:txBody>
+                    <a:bodyPr/>
+                    <a:lstStyle/>
+                    <a:p>
+                      <a:pPr rtl="0" fontAlgn="b">
+                        <a:buNone/>
+                      </a:pPr>
+                      <a:r>
+                        <a:rPr lang="de-AT" dirty="0">
+                          <a:solidFill>
+                            <a:srgbClr val="F5F6FA"/>
+                          </a:solidFill>
+                          <a:effectLst/>
+                        </a:rPr>
+                        <a:t>Content Schedule Capstone Project</a:t>
+                      </a:r>
+                    </a:p>
+                  </a:txBody>
+                  <a:tcPr marL="22860" marR="22860" marT="0" marB="0" anchor="b">
+                    <a:lnL w="7620" cap="flat" cmpd="sng" algn="ctr">
+                      <a:solidFill>
+                        <a:srgbClr val="CCCCCC"/>
+                      </a:solidFill>
+                      <a:prstDash val="solid"/>
+                      <a:round/>
+                      <a:headEnd type="none" w="med" len="med"/>
+                      <a:tailEnd type="none" w="med" len="med"/>
+                    </a:lnL>
+                    <a:lnR w="7620" cap="flat" cmpd="sng" algn="ctr">
+                      <a:solidFill>
+                        <a:srgbClr val="CCCCCC"/>
+                      </a:solidFill>
+                      <a:prstDash val="solid"/>
+                      <a:round/>
+                      <a:headEnd type="none" w="med" len="med"/>
+                      <a:tailEnd type="none" w="med" len="med"/>
+                    </a:lnR>
+                    <a:lnT w="7620" cap="flat" cmpd="sng" algn="ctr">
+                      <a:solidFill>
+                        <a:srgbClr val="CCCCCC"/>
+                      </a:solidFill>
+                      <a:prstDash val="solid"/>
+                      <a:round/>
+                      <a:headEnd type="none" w="med" len="med"/>
+                      <a:tailEnd type="none" w="med" len="med"/>
+                    </a:lnT>
+                    <a:lnB w="7620" cap="flat" cmpd="sng" algn="ctr">
+                      <a:solidFill>
+                        <a:srgbClr val="CCCCCC"/>
+                      </a:solidFill>
+                      <a:prstDash val="solid"/>
+                      <a:round/>
+                      <a:headEnd type="none" w="med" len="med"/>
+                      <a:tailEnd type="none" w="med" len="med"/>
+                    </a:lnB>
+                    <a:noFill/>
+                  </a:tcPr>
+                </a:tc>
+                <a:tc>
+                  <a:txBody>
+                    <a:bodyPr/>
+                    <a:lstStyle/>
+                    <a:p>
+                      <a:pPr rtl="0" fontAlgn="b">
+                        <a:buNone/>
+                      </a:pPr>
+                      <a:endParaRPr lang="en-US" dirty="0">
+                        <a:solidFill>
+                          <a:srgbClr val="F5F6FA"/>
+                        </a:solidFill>
+                        <a:effectLst/>
+                      </a:endParaRPr>
+                    </a:p>
+                  </a:txBody>
+                  <a:tcPr marL="22860" marR="22860" marT="0" marB="0" anchor="b">
+                    <a:lnL w="7620" cap="flat" cmpd="sng" algn="ctr">
+                      <a:solidFill>
+                        <a:srgbClr val="CCCCCC"/>
+                      </a:solidFill>
+                      <a:prstDash val="solid"/>
+                      <a:round/>
+                      <a:headEnd type="none" w="med" len="med"/>
+                      <a:tailEnd type="none" w="med" len="med"/>
+                    </a:lnL>
+                    <a:lnR w="7620" cap="flat" cmpd="sng" algn="ctr">
+                      <a:solidFill>
+                        <a:srgbClr val="CCCCCC"/>
+                      </a:solidFill>
+                      <a:prstDash val="solid"/>
+                      <a:round/>
+                      <a:headEnd type="none" w="med" len="med"/>
+                      <a:tailEnd type="none" w="med" len="med"/>
+                    </a:lnR>
+                    <a:lnT w="7620" cap="flat" cmpd="sng" algn="ctr">
+                      <a:solidFill>
+                        <a:srgbClr val="CCCCCC"/>
+                      </a:solidFill>
+                      <a:prstDash val="solid"/>
+                      <a:round/>
+                      <a:headEnd type="none" w="med" len="med"/>
+                      <a:tailEnd type="none" w="med" len="med"/>
+                    </a:lnT>
+                    <a:lnB w="7620" cap="flat" cmpd="sng" algn="ctr">
+                      <a:solidFill>
+                        <a:srgbClr val="CCCCCC"/>
+                      </a:solidFill>
+                      <a:prstDash val="solid"/>
+                      <a:round/>
+                      <a:headEnd type="none" w="med" len="med"/>
+                      <a:tailEnd type="none" w="med" len="med"/>
+                    </a:lnB>
+                    <a:noFill/>
+                  </a:tcPr>
+                </a:tc>
+                <a:extLst>
+                  <a:ext uri="{0D108BD9-81ED-4DB2-BD59-A6C34878D82A}">
+                    <a16:rowId xmlns:a16="http://schemas.microsoft.com/office/drawing/2014/main" val="3583059865"/>
+                  </a:ext>
+                </a:extLst>
+              </a:tr>
+              <a:tr h="160020">
+                <a:tc>
+                  <a:txBody>
+                    <a:bodyPr/>
+                    <a:lstStyle/>
+                    <a:p>
+                      <a:pPr rtl="0" fontAlgn="b">
+                        <a:buNone/>
+                      </a:pPr>
+                      <a:r>
+                        <a:rPr lang="de-AT" dirty="0">
+                          <a:solidFill>
+                            <a:srgbClr val="F5F6FA"/>
+                          </a:solidFill>
+                          <a:effectLst/>
+                        </a:rPr>
+                        <a:t>Domain </a:t>
+                      </a:r>
+                      <a:r>
+                        <a:rPr lang="de-AT" dirty="0" err="1">
+                          <a:solidFill>
+                            <a:srgbClr val="F5F6FA"/>
+                          </a:solidFill>
+                          <a:effectLst/>
+                        </a:rPr>
+                        <a:t>knowledge</a:t>
+                      </a:r>
+                      <a:r>
+                        <a:rPr lang="de-AT" dirty="0">
+                          <a:solidFill>
+                            <a:srgbClr val="F5F6FA"/>
+                          </a:solidFill>
+                          <a:effectLst/>
+                        </a:rPr>
+                        <a:t>: </a:t>
+                      </a:r>
+                      <a:r>
+                        <a:rPr lang="de-AT" dirty="0" err="1">
+                          <a:solidFill>
+                            <a:srgbClr val="F5F6FA"/>
+                          </a:solidFill>
+                          <a:effectLst/>
+                        </a:rPr>
+                        <a:t>Product</a:t>
+                      </a:r>
+                      <a:r>
+                        <a:rPr lang="de-AT" dirty="0">
+                          <a:solidFill>
+                            <a:srgbClr val="F5F6FA"/>
+                          </a:solidFill>
+                          <a:effectLst/>
+                        </a:rPr>
+                        <a:t> </a:t>
+                      </a:r>
+                      <a:r>
+                        <a:rPr lang="de-AT" dirty="0" err="1">
+                          <a:solidFill>
+                            <a:srgbClr val="F5F6FA"/>
+                          </a:solidFill>
+                          <a:effectLst/>
+                        </a:rPr>
+                        <a:t>Thinking</a:t>
+                      </a:r>
+                      <a:endParaRPr lang="de-AT" dirty="0">
+                        <a:solidFill>
+                          <a:srgbClr val="F5F6FA"/>
+                        </a:solidFill>
+                        <a:effectLst/>
+                      </a:endParaRPr>
+                    </a:p>
+                  </a:txBody>
+                  <a:tcPr marL="22860" marR="22860" marT="0" marB="0" anchor="b">
+                    <a:lnL w="7620" cap="flat" cmpd="sng" algn="ctr">
+                      <a:solidFill>
+                        <a:srgbClr val="CCCCCC"/>
+                      </a:solidFill>
+                      <a:prstDash val="solid"/>
+                      <a:round/>
+                      <a:headEnd type="none" w="med" len="med"/>
+                      <a:tailEnd type="none" w="med" len="med"/>
+                    </a:lnL>
+                    <a:lnR w="7620" cap="flat" cmpd="sng" algn="ctr">
+                      <a:solidFill>
+                        <a:srgbClr val="CCCCCC"/>
+                      </a:solidFill>
+                      <a:prstDash val="solid"/>
+                      <a:round/>
+                      <a:headEnd type="none" w="med" len="med"/>
+                      <a:tailEnd type="none" w="med" len="med"/>
+                    </a:lnR>
+                    <a:lnT w="7620" cap="flat" cmpd="sng" algn="ctr">
+                      <a:solidFill>
+                        <a:srgbClr val="CCCCCC"/>
+                      </a:solidFill>
+                      <a:prstDash val="solid"/>
+                      <a:round/>
+                      <a:headEnd type="none" w="med" len="med"/>
+                      <a:tailEnd type="none" w="med" len="med"/>
+                    </a:lnT>
+                    <a:lnB w="7620" cap="flat" cmpd="sng" algn="ctr">
+                      <a:solidFill>
+                        <a:srgbClr val="CCCCCC"/>
+                      </a:solidFill>
+                      <a:prstDash val="solid"/>
+                      <a:round/>
+                      <a:headEnd type="none" w="med" len="med"/>
+                      <a:tailEnd type="none" w="med" len="med"/>
+                    </a:lnB>
+                    <a:noFill/>
+                  </a:tcPr>
+                </a:tc>
+                <a:tc>
+                  <a:txBody>
+                    <a:bodyPr/>
+                    <a:lstStyle/>
+                    <a:p>
+                      <a:pPr rtl="0" fontAlgn="b">
+                        <a:buNone/>
+                      </a:pPr>
+                      <a:endParaRPr lang="en-US" dirty="0">
+                        <a:solidFill>
+                          <a:srgbClr val="F5F6FA"/>
+                        </a:solidFill>
+                        <a:effectLst/>
+                      </a:endParaRPr>
+                    </a:p>
+                  </a:txBody>
+                  <a:tcPr marL="22860" marR="22860" marT="0" marB="0" anchor="b">
+                    <a:lnL w="7620" cap="flat" cmpd="sng" algn="ctr">
+                      <a:solidFill>
+                        <a:srgbClr val="CCCCCC"/>
+                      </a:solidFill>
+                      <a:prstDash val="solid"/>
+                      <a:round/>
+                      <a:headEnd type="none" w="med" len="med"/>
+                      <a:tailEnd type="none" w="med" len="med"/>
+                    </a:lnL>
+                    <a:lnR w="7620" cap="flat" cmpd="sng" algn="ctr">
+                      <a:solidFill>
+                        <a:srgbClr val="CCCCCC"/>
+                      </a:solidFill>
+                      <a:prstDash val="solid"/>
+                      <a:round/>
+                      <a:headEnd type="none" w="med" len="med"/>
+                      <a:tailEnd type="none" w="med" len="med"/>
+                    </a:lnR>
+                    <a:lnT w="7620" cap="flat" cmpd="sng" algn="ctr">
+                      <a:solidFill>
+                        <a:srgbClr val="CCCCCC"/>
+                      </a:solidFill>
+                      <a:prstDash val="solid"/>
+                      <a:round/>
+                      <a:headEnd type="none" w="med" len="med"/>
+                      <a:tailEnd type="none" w="med" len="med"/>
+                    </a:lnT>
+                    <a:lnB w="7620" cap="flat" cmpd="sng" algn="ctr">
+                      <a:solidFill>
+                        <a:srgbClr val="CCCCCC"/>
+                      </a:solidFill>
+                      <a:prstDash val="solid"/>
+                      <a:round/>
+                      <a:headEnd type="none" w="med" len="med"/>
+                      <a:tailEnd type="none" w="med" len="med"/>
+                    </a:lnB>
+                    <a:noFill/>
+                  </a:tcPr>
+                </a:tc>
+                <a:extLst>
+                  <a:ext uri="{0D108BD9-81ED-4DB2-BD59-A6C34878D82A}">
+                    <a16:rowId xmlns:a16="http://schemas.microsoft.com/office/drawing/2014/main" val="3284658464"/>
+                  </a:ext>
+                </a:extLst>
+              </a:tr>
+              <a:tr h="160020">
+                <a:tc>
+                  <a:txBody>
+                    <a:bodyPr/>
+                    <a:lstStyle/>
+                    <a:p>
+                      <a:pPr rtl="0" fontAlgn="b">
+                        <a:buNone/>
+                      </a:pPr>
+                      <a:r>
+                        <a:rPr lang="de-AT" dirty="0">
+                          <a:solidFill>
+                            <a:srgbClr val="F5F6FA"/>
+                          </a:solidFill>
+                          <a:effectLst/>
+                        </a:rPr>
+                        <a:t>Agile Project Management</a:t>
+                      </a:r>
+                    </a:p>
+                  </a:txBody>
+                  <a:tcPr marL="22860" marR="22860" marT="0" marB="0" anchor="b">
+                    <a:lnL w="7620" cap="flat" cmpd="sng" algn="ctr">
+                      <a:solidFill>
+                        <a:srgbClr val="CCCCCC"/>
+                      </a:solidFill>
+                      <a:prstDash val="solid"/>
+                      <a:round/>
+                      <a:headEnd type="none" w="med" len="med"/>
+                      <a:tailEnd type="none" w="med" len="med"/>
+                    </a:lnL>
+                    <a:lnR w="7620" cap="flat" cmpd="sng" algn="ctr">
+                      <a:solidFill>
+                        <a:srgbClr val="CCCCCC"/>
+                      </a:solidFill>
+                      <a:prstDash val="solid"/>
+                      <a:round/>
+                      <a:headEnd type="none" w="med" len="med"/>
+                      <a:tailEnd type="none" w="med" len="med"/>
+                    </a:lnR>
+                    <a:lnT w="7620" cap="flat" cmpd="sng" algn="ctr">
+                      <a:solidFill>
+                        <a:srgbClr val="CCCCCC"/>
+                      </a:solidFill>
+                      <a:prstDash val="solid"/>
+                      <a:round/>
+                      <a:headEnd type="none" w="med" len="med"/>
+                      <a:tailEnd type="none" w="med" len="med"/>
+                    </a:lnT>
+                    <a:lnB w="7620" cap="flat" cmpd="sng" algn="ctr">
+                      <a:solidFill>
+                        <a:srgbClr val="CCCCCC"/>
+                      </a:solidFill>
+                      <a:prstDash val="solid"/>
+                      <a:round/>
+                      <a:headEnd type="none" w="med" len="med"/>
+                      <a:tailEnd type="none" w="med" len="med"/>
+                    </a:lnB>
+                    <a:noFill/>
+                  </a:tcPr>
+                </a:tc>
+                <a:tc>
+                  <a:txBody>
+                    <a:bodyPr/>
+                    <a:lstStyle/>
+                    <a:p>
+                      <a:pPr rtl="0" fontAlgn="b">
+                        <a:buNone/>
+                      </a:pPr>
+                      <a:r>
+                        <a:rPr lang="de-AT" dirty="0">
+                          <a:solidFill>
+                            <a:srgbClr val="F5F6FA"/>
+                          </a:solidFill>
+                          <a:effectLst/>
+                        </a:rPr>
+                        <a:t>-&gt;</a:t>
+                      </a:r>
+                      <a:r>
+                        <a:rPr lang="de-AT" dirty="0" err="1">
+                          <a:solidFill>
+                            <a:srgbClr val="F5F6FA"/>
+                          </a:solidFill>
+                          <a:effectLst/>
+                        </a:rPr>
+                        <a:t>present</a:t>
+                      </a:r>
+                      <a:r>
+                        <a:rPr lang="de-AT" dirty="0">
+                          <a:solidFill>
+                            <a:srgbClr val="F5F6FA"/>
+                          </a:solidFill>
+                          <a:effectLst/>
+                        </a:rPr>
+                        <a:t> </a:t>
+                      </a:r>
+                      <a:r>
+                        <a:rPr lang="de-AT" dirty="0" err="1">
+                          <a:solidFill>
+                            <a:srgbClr val="F5F6FA"/>
+                          </a:solidFill>
+                          <a:effectLst/>
+                        </a:rPr>
+                        <a:t>project</a:t>
+                      </a:r>
+                      <a:r>
+                        <a:rPr lang="de-AT" dirty="0">
+                          <a:solidFill>
+                            <a:srgbClr val="F5F6FA"/>
+                          </a:solidFill>
+                          <a:effectLst/>
+                        </a:rPr>
+                        <a:t> </a:t>
+                      </a:r>
+                      <a:r>
+                        <a:rPr lang="de-AT" dirty="0" err="1">
+                          <a:solidFill>
+                            <a:srgbClr val="F5F6FA"/>
+                          </a:solidFill>
+                          <a:effectLst/>
+                        </a:rPr>
+                        <a:t>timeline</a:t>
+                      </a:r>
+                      <a:r>
+                        <a:rPr lang="de-AT" dirty="0">
+                          <a:solidFill>
+                            <a:srgbClr val="F5F6FA"/>
+                          </a:solidFill>
+                          <a:effectLst/>
+                        </a:rPr>
+                        <a:t> &amp; </a:t>
+                      </a:r>
+                      <a:r>
+                        <a:rPr lang="de-AT" dirty="0" err="1">
+                          <a:solidFill>
+                            <a:srgbClr val="F5F6FA"/>
+                          </a:solidFill>
+                          <a:effectLst/>
+                        </a:rPr>
+                        <a:t>how</a:t>
+                      </a:r>
+                      <a:r>
+                        <a:rPr lang="de-AT" dirty="0">
+                          <a:solidFill>
+                            <a:srgbClr val="F5F6FA"/>
+                          </a:solidFill>
+                          <a:effectLst/>
+                        </a:rPr>
+                        <a:t> </a:t>
+                      </a:r>
+                      <a:r>
+                        <a:rPr lang="de-AT" dirty="0" err="1">
+                          <a:solidFill>
+                            <a:srgbClr val="F5F6FA"/>
+                          </a:solidFill>
+                          <a:effectLst/>
+                        </a:rPr>
+                        <a:t>modules</a:t>
+                      </a:r>
+                      <a:r>
+                        <a:rPr lang="de-AT" dirty="0">
+                          <a:solidFill>
+                            <a:srgbClr val="F5F6FA"/>
+                          </a:solidFill>
+                          <a:effectLst/>
+                        </a:rPr>
+                        <a:t> in </a:t>
+                      </a:r>
+                      <a:r>
+                        <a:rPr lang="de-AT" dirty="0" err="1">
+                          <a:solidFill>
+                            <a:srgbClr val="F5F6FA"/>
+                          </a:solidFill>
+                          <a:effectLst/>
+                        </a:rPr>
+                        <a:t>project</a:t>
+                      </a:r>
+                      <a:r>
+                        <a:rPr lang="de-AT" dirty="0">
+                          <a:solidFill>
+                            <a:srgbClr val="F5F6FA"/>
+                          </a:solidFill>
+                          <a:effectLst/>
+                        </a:rPr>
+                        <a:t> </a:t>
+                      </a:r>
+                      <a:r>
+                        <a:rPr lang="de-AT" dirty="0" err="1">
+                          <a:solidFill>
+                            <a:srgbClr val="F5F6FA"/>
+                          </a:solidFill>
+                          <a:effectLst/>
+                        </a:rPr>
+                        <a:t>interact</a:t>
+                      </a:r>
+                      <a:endParaRPr lang="de-AT" dirty="0">
+                        <a:solidFill>
+                          <a:srgbClr val="F5F6FA"/>
+                        </a:solidFill>
+                        <a:effectLst/>
+                      </a:endParaRPr>
+                    </a:p>
+                  </a:txBody>
+                  <a:tcPr marL="22860" marR="22860" marT="0" marB="0" anchor="b">
+                    <a:lnL w="7620" cap="flat" cmpd="sng" algn="ctr">
+                      <a:solidFill>
+                        <a:srgbClr val="CCCCCC"/>
+                      </a:solidFill>
+                      <a:prstDash val="solid"/>
+                      <a:round/>
+                      <a:headEnd type="none" w="med" len="med"/>
+                      <a:tailEnd type="none" w="med" len="med"/>
+                    </a:lnL>
+                    <a:lnR w="7620" cap="flat" cmpd="sng" algn="ctr">
+                      <a:solidFill>
+                        <a:srgbClr val="CCCCCC"/>
+                      </a:solidFill>
+                      <a:prstDash val="solid"/>
+                      <a:round/>
+                      <a:headEnd type="none" w="med" len="med"/>
+                      <a:tailEnd type="none" w="med" len="med"/>
+                    </a:lnR>
+                    <a:lnT w="7620" cap="flat" cmpd="sng" algn="ctr">
+                      <a:solidFill>
+                        <a:srgbClr val="CCCCCC"/>
+                      </a:solidFill>
+                      <a:prstDash val="solid"/>
+                      <a:round/>
+                      <a:headEnd type="none" w="med" len="med"/>
+                      <a:tailEnd type="none" w="med" len="med"/>
+                    </a:lnT>
+                    <a:lnB w="7620" cap="flat" cmpd="sng" algn="ctr">
+                      <a:solidFill>
+                        <a:srgbClr val="CCCCCC"/>
+                      </a:solidFill>
+                      <a:prstDash val="solid"/>
+                      <a:round/>
+                      <a:headEnd type="none" w="med" len="med"/>
+                      <a:tailEnd type="none" w="med" len="med"/>
+                    </a:lnB>
+                    <a:noFill/>
+                  </a:tcPr>
+                </a:tc>
+                <a:extLst>
+                  <a:ext uri="{0D108BD9-81ED-4DB2-BD59-A6C34878D82A}">
+                    <a16:rowId xmlns:a16="http://schemas.microsoft.com/office/drawing/2014/main" val="2375521707"/>
+                  </a:ext>
+                </a:extLst>
+              </a:tr>
+              <a:tr h="160020">
+                <a:tc>
+                  <a:txBody>
+                    <a:bodyPr/>
+                    <a:lstStyle/>
+                    <a:p>
+                      <a:pPr rtl="0" fontAlgn="b">
+                        <a:buNone/>
+                      </a:pPr>
+                      <a:r>
+                        <a:rPr lang="de-AT" dirty="0">
+                          <a:solidFill>
+                            <a:srgbClr val="F5F6FA"/>
+                          </a:solidFill>
+                          <a:effectLst/>
+                        </a:rPr>
+                        <a:t>Communication: Writing &amp; </a:t>
+                      </a:r>
+                      <a:r>
+                        <a:rPr lang="de-AT" dirty="0" err="1">
+                          <a:solidFill>
+                            <a:srgbClr val="F5F6FA"/>
+                          </a:solidFill>
+                          <a:effectLst/>
+                        </a:rPr>
+                        <a:t>Presentation</a:t>
+                      </a:r>
+                      <a:endParaRPr lang="de-AT" dirty="0">
+                        <a:solidFill>
+                          <a:srgbClr val="F5F6FA"/>
+                        </a:solidFill>
+                        <a:effectLst/>
+                      </a:endParaRPr>
+                    </a:p>
+                  </a:txBody>
+                  <a:tcPr marL="22860" marR="22860" marT="0" marB="0" anchor="b">
+                    <a:lnL w="7620" cap="flat" cmpd="sng" algn="ctr">
+                      <a:solidFill>
+                        <a:srgbClr val="CCCCCC"/>
+                      </a:solidFill>
+                      <a:prstDash val="solid"/>
+                      <a:round/>
+                      <a:headEnd type="none" w="med" len="med"/>
+                      <a:tailEnd type="none" w="med" len="med"/>
+                    </a:lnL>
+                    <a:lnR w="7620" cap="flat" cmpd="sng" algn="ctr">
+                      <a:solidFill>
+                        <a:srgbClr val="CCCCCC"/>
+                      </a:solidFill>
+                      <a:prstDash val="solid"/>
+                      <a:round/>
+                      <a:headEnd type="none" w="med" len="med"/>
+                      <a:tailEnd type="none" w="med" len="med"/>
+                    </a:lnR>
+                    <a:lnT w="7620" cap="flat" cmpd="sng" algn="ctr">
+                      <a:solidFill>
+                        <a:srgbClr val="CCCCCC"/>
+                      </a:solidFill>
+                      <a:prstDash val="solid"/>
+                      <a:round/>
+                      <a:headEnd type="none" w="med" len="med"/>
+                      <a:tailEnd type="none" w="med" len="med"/>
+                    </a:lnT>
+                    <a:lnB w="7620" cap="flat" cmpd="sng" algn="ctr">
+                      <a:solidFill>
+                        <a:srgbClr val="CCCCCC"/>
+                      </a:solidFill>
+                      <a:prstDash val="solid"/>
+                      <a:round/>
+                      <a:headEnd type="none" w="med" len="med"/>
+                      <a:tailEnd type="none" w="med" len="med"/>
+                    </a:lnB>
+                    <a:noFill/>
+                  </a:tcPr>
+                </a:tc>
+                <a:tc>
+                  <a:txBody>
+                    <a:bodyPr/>
+                    <a:lstStyle/>
+                    <a:p>
+                      <a:pPr rtl="0" fontAlgn="b">
+                        <a:buNone/>
+                      </a:pPr>
+                      <a:endParaRPr lang="en-US" dirty="0">
+                        <a:solidFill>
+                          <a:srgbClr val="F5F6FA"/>
+                        </a:solidFill>
+                        <a:effectLst/>
+                      </a:endParaRPr>
+                    </a:p>
+                  </a:txBody>
+                  <a:tcPr marL="22860" marR="22860" marT="0" marB="0" anchor="b">
+                    <a:lnL w="7620" cap="flat" cmpd="sng" algn="ctr">
+                      <a:solidFill>
+                        <a:srgbClr val="CCCCCC"/>
+                      </a:solidFill>
+                      <a:prstDash val="solid"/>
+                      <a:round/>
+                      <a:headEnd type="none" w="med" len="med"/>
+                      <a:tailEnd type="none" w="med" len="med"/>
+                    </a:lnL>
+                    <a:lnR w="7620" cap="flat" cmpd="sng" algn="ctr">
+                      <a:solidFill>
+                        <a:srgbClr val="CCCCCC"/>
+                      </a:solidFill>
+                      <a:prstDash val="solid"/>
+                      <a:round/>
+                      <a:headEnd type="none" w="med" len="med"/>
+                      <a:tailEnd type="none" w="med" len="med"/>
+                    </a:lnR>
+                    <a:lnT w="7620" cap="flat" cmpd="sng" algn="ctr">
+                      <a:solidFill>
+                        <a:srgbClr val="CCCCCC"/>
+                      </a:solidFill>
+                      <a:prstDash val="solid"/>
+                      <a:round/>
+                      <a:headEnd type="none" w="med" len="med"/>
+                      <a:tailEnd type="none" w="med" len="med"/>
+                    </a:lnT>
+                    <a:lnB w="7620" cap="flat" cmpd="sng" algn="ctr">
+                      <a:solidFill>
+                        <a:srgbClr val="CCCCCC"/>
+                      </a:solidFill>
+                      <a:prstDash val="solid"/>
+                      <a:round/>
+                      <a:headEnd type="none" w="med" len="med"/>
+                      <a:tailEnd type="none" w="med" len="med"/>
+                    </a:lnB>
+                    <a:noFill/>
+                  </a:tcPr>
+                </a:tc>
+                <a:extLst>
+                  <a:ext uri="{0D108BD9-81ED-4DB2-BD59-A6C34878D82A}">
+                    <a16:rowId xmlns:a16="http://schemas.microsoft.com/office/drawing/2014/main" val="1353282417"/>
+                  </a:ext>
+                </a:extLst>
+              </a:tr>
+              <a:tr h="160020">
+                <a:tc>
+                  <a:txBody>
+                    <a:bodyPr/>
+                    <a:lstStyle/>
+                    <a:p>
+                      <a:pPr rtl="0" fontAlgn="b">
+                        <a:buNone/>
+                      </a:pPr>
+                      <a:r>
+                        <a:rPr lang="de-AT" dirty="0">
+                          <a:solidFill>
+                            <a:srgbClr val="F5F6FA"/>
+                          </a:solidFill>
+                          <a:effectLst/>
+                        </a:rPr>
+                        <a:t>EDA: Data </a:t>
+                      </a:r>
+                      <a:r>
+                        <a:rPr lang="de-AT" dirty="0" err="1">
+                          <a:solidFill>
+                            <a:srgbClr val="F5F6FA"/>
+                          </a:solidFill>
+                          <a:effectLst/>
+                        </a:rPr>
+                        <a:t>Visualization</a:t>
+                      </a:r>
+                      <a:r>
+                        <a:rPr lang="de-AT" dirty="0">
+                          <a:solidFill>
+                            <a:srgbClr val="F5F6FA"/>
+                          </a:solidFill>
+                          <a:effectLst/>
+                        </a:rPr>
+                        <a:t> &amp; Exploration</a:t>
+                      </a:r>
+                    </a:p>
+                  </a:txBody>
+                  <a:tcPr marL="22860" marR="22860" marT="0" marB="0" anchor="b">
+                    <a:lnL w="7620" cap="flat" cmpd="sng" algn="ctr">
+                      <a:solidFill>
+                        <a:srgbClr val="CCCCCC"/>
+                      </a:solidFill>
+                      <a:prstDash val="solid"/>
+                      <a:round/>
+                      <a:headEnd type="none" w="med" len="med"/>
+                      <a:tailEnd type="none" w="med" len="med"/>
+                    </a:lnL>
+                    <a:lnR w="7620" cap="flat" cmpd="sng" algn="ctr">
+                      <a:solidFill>
+                        <a:srgbClr val="CCCCCC"/>
+                      </a:solidFill>
+                      <a:prstDash val="solid"/>
+                      <a:round/>
+                      <a:headEnd type="none" w="med" len="med"/>
+                      <a:tailEnd type="none" w="med" len="med"/>
+                    </a:lnR>
+                    <a:lnT w="7620" cap="flat" cmpd="sng" algn="ctr">
+                      <a:solidFill>
+                        <a:srgbClr val="CCCCCC"/>
+                      </a:solidFill>
+                      <a:prstDash val="solid"/>
+                      <a:round/>
+                      <a:headEnd type="none" w="med" len="med"/>
+                      <a:tailEnd type="none" w="med" len="med"/>
+                    </a:lnT>
+                    <a:lnB w="7620" cap="flat" cmpd="sng" algn="ctr">
+                      <a:solidFill>
+                        <a:srgbClr val="CCCCCC"/>
+                      </a:solidFill>
+                      <a:prstDash val="solid"/>
+                      <a:round/>
+                      <a:headEnd type="none" w="med" len="med"/>
+                      <a:tailEnd type="none" w="med" len="med"/>
+                    </a:lnB>
+                    <a:noFill/>
+                  </a:tcPr>
+                </a:tc>
+                <a:tc>
+                  <a:txBody>
+                    <a:bodyPr/>
+                    <a:lstStyle/>
+                    <a:p>
+                      <a:pPr rtl="0" fontAlgn="b">
+                        <a:buNone/>
+                      </a:pPr>
+                      <a:endParaRPr lang="en-US" dirty="0">
+                        <a:solidFill>
+                          <a:srgbClr val="F5F6FA"/>
+                        </a:solidFill>
+                        <a:effectLst/>
+                      </a:endParaRPr>
+                    </a:p>
+                  </a:txBody>
+                  <a:tcPr marL="22860" marR="22860" marT="0" marB="0" anchor="b">
+                    <a:lnL w="7620" cap="flat" cmpd="sng" algn="ctr">
+                      <a:solidFill>
+                        <a:srgbClr val="CCCCCC"/>
+                      </a:solidFill>
+                      <a:prstDash val="solid"/>
+                      <a:round/>
+                      <a:headEnd type="none" w="med" len="med"/>
+                      <a:tailEnd type="none" w="med" len="med"/>
+                    </a:lnL>
+                    <a:lnR w="7620" cap="flat" cmpd="sng" algn="ctr">
+                      <a:solidFill>
+                        <a:srgbClr val="CCCCCC"/>
+                      </a:solidFill>
+                      <a:prstDash val="solid"/>
+                      <a:round/>
+                      <a:headEnd type="none" w="med" len="med"/>
+                      <a:tailEnd type="none" w="med" len="med"/>
+                    </a:lnR>
+                    <a:lnT w="7620" cap="flat" cmpd="sng" algn="ctr">
+                      <a:solidFill>
+                        <a:srgbClr val="CCCCCC"/>
+                      </a:solidFill>
+                      <a:prstDash val="solid"/>
+                      <a:round/>
+                      <a:headEnd type="none" w="med" len="med"/>
+                      <a:tailEnd type="none" w="med" len="med"/>
+                    </a:lnT>
+                    <a:lnB w="7620" cap="flat" cmpd="sng" algn="ctr">
+                      <a:solidFill>
+                        <a:srgbClr val="CCCCCC"/>
+                      </a:solidFill>
+                      <a:prstDash val="solid"/>
+                      <a:round/>
+                      <a:headEnd type="none" w="med" len="med"/>
+                      <a:tailEnd type="none" w="med" len="med"/>
+                    </a:lnB>
+                    <a:noFill/>
+                  </a:tcPr>
+                </a:tc>
+                <a:extLst>
+                  <a:ext uri="{0D108BD9-81ED-4DB2-BD59-A6C34878D82A}">
+                    <a16:rowId xmlns:a16="http://schemas.microsoft.com/office/drawing/2014/main" val="961260673"/>
+                  </a:ext>
+                </a:extLst>
+              </a:tr>
+              <a:tr h="160020">
+                <a:tc>
+                  <a:txBody>
+                    <a:bodyPr/>
+                    <a:lstStyle/>
+                    <a:p>
+                      <a:pPr rtl="0" fontAlgn="b">
+                        <a:buNone/>
+                      </a:pPr>
+                      <a:r>
+                        <a:rPr lang="de-AT" dirty="0">
+                          <a:solidFill>
+                            <a:srgbClr val="F5F6FA"/>
+                          </a:solidFill>
+                          <a:effectLst/>
+                        </a:rPr>
+                        <a:t>Modeling / </a:t>
+                      </a:r>
+                      <a:r>
+                        <a:rPr lang="de-AT" dirty="0" err="1">
+                          <a:solidFill>
+                            <a:srgbClr val="F5F6FA"/>
+                          </a:solidFill>
+                          <a:effectLst/>
+                        </a:rPr>
+                        <a:t>Statistics</a:t>
+                      </a:r>
+                      <a:endParaRPr lang="de-AT" dirty="0">
+                        <a:solidFill>
+                          <a:srgbClr val="F5F6FA"/>
+                        </a:solidFill>
+                        <a:effectLst/>
+                      </a:endParaRPr>
+                    </a:p>
+                  </a:txBody>
+                  <a:tcPr marL="22860" marR="22860" marT="0" marB="0" anchor="b">
+                    <a:lnL w="7620" cap="flat" cmpd="sng" algn="ctr">
+                      <a:solidFill>
+                        <a:srgbClr val="CCCCCC"/>
+                      </a:solidFill>
+                      <a:prstDash val="solid"/>
+                      <a:round/>
+                      <a:headEnd type="none" w="med" len="med"/>
+                      <a:tailEnd type="none" w="med" len="med"/>
+                    </a:lnL>
+                    <a:lnR w="7620" cap="flat" cmpd="sng" algn="ctr">
+                      <a:solidFill>
+                        <a:srgbClr val="CCCCCC"/>
+                      </a:solidFill>
+                      <a:prstDash val="solid"/>
+                      <a:round/>
+                      <a:headEnd type="none" w="med" len="med"/>
+                      <a:tailEnd type="none" w="med" len="med"/>
+                    </a:lnR>
+                    <a:lnT w="7620" cap="flat" cmpd="sng" algn="ctr">
+                      <a:solidFill>
+                        <a:srgbClr val="CCCCCC"/>
+                      </a:solidFill>
+                      <a:prstDash val="solid"/>
+                      <a:round/>
+                      <a:headEnd type="none" w="med" len="med"/>
+                      <a:tailEnd type="none" w="med" len="med"/>
+                    </a:lnT>
+                    <a:lnB w="7620" cap="flat" cmpd="sng" algn="ctr">
+                      <a:solidFill>
+                        <a:srgbClr val="CCCCCC"/>
+                      </a:solidFill>
+                      <a:prstDash val="solid"/>
+                      <a:round/>
+                      <a:headEnd type="none" w="med" len="med"/>
+                      <a:tailEnd type="none" w="med" len="med"/>
+                    </a:lnB>
+                    <a:noFill/>
+                  </a:tcPr>
+                </a:tc>
+                <a:tc>
+                  <a:txBody>
+                    <a:bodyPr/>
+                    <a:lstStyle/>
+                    <a:p>
+                      <a:pPr rtl="0" fontAlgn="b">
+                        <a:buNone/>
+                      </a:pPr>
+                      <a:endParaRPr lang="en-US" dirty="0">
+                        <a:solidFill>
+                          <a:srgbClr val="F5F6FA"/>
+                        </a:solidFill>
+                        <a:effectLst/>
+                      </a:endParaRPr>
+                    </a:p>
+                  </a:txBody>
+                  <a:tcPr marL="22860" marR="22860" marT="0" marB="0" anchor="b">
+                    <a:lnL w="7620" cap="flat" cmpd="sng" algn="ctr">
+                      <a:solidFill>
+                        <a:srgbClr val="CCCCCC"/>
+                      </a:solidFill>
+                      <a:prstDash val="solid"/>
+                      <a:round/>
+                      <a:headEnd type="none" w="med" len="med"/>
+                      <a:tailEnd type="none" w="med" len="med"/>
+                    </a:lnL>
+                    <a:lnR w="7620" cap="flat" cmpd="sng" algn="ctr">
+                      <a:solidFill>
+                        <a:srgbClr val="CCCCCC"/>
+                      </a:solidFill>
+                      <a:prstDash val="solid"/>
+                      <a:round/>
+                      <a:headEnd type="none" w="med" len="med"/>
+                      <a:tailEnd type="none" w="med" len="med"/>
+                    </a:lnR>
+                    <a:lnT w="7620" cap="flat" cmpd="sng" algn="ctr">
+                      <a:solidFill>
+                        <a:srgbClr val="CCCCCC"/>
+                      </a:solidFill>
+                      <a:prstDash val="solid"/>
+                      <a:round/>
+                      <a:headEnd type="none" w="med" len="med"/>
+                      <a:tailEnd type="none" w="med" len="med"/>
+                    </a:lnT>
+                    <a:lnB w="7620" cap="flat" cmpd="sng" algn="ctr">
+                      <a:solidFill>
+                        <a:srgbClr val="CCCCCC"/>
+                      </a:solidFill>
+                      <a:prstDash val="solid"/>
+                      <a:round/>
+                      <a:headEnd type="none" w="med" len="med"/>
+                      <a:tailEnd type="none" w="med" len="med"/>
+                    </a:lnB>
+                    <a:noFill/>
+                  </a:tcPr>
+                </a:tc>
+                <a:extLst>
+                  <a:ext uri="{0D108BD9-81ED-4DB2-BD59-A6C34878D82A}">
+                    <a16:rowId xmlns:a16="http://schemas.microsoft.com/office/drawing/2014/main" val="31889897"/>
+                  </a:ext>
+                </a:extLst>
+              </a:tr>
+              <a:tr h="160020">
+                <a:tc>
+                  <a:txBody>
+                    <a:bodyPr/>
+                    <a:lstStyle/>
+                    <a:p>
+                      <a:pPr rtl="0" fontAlgn="b">
+                        <a:buNone/>
+                      </a:pPr>
+                      <a:r>
+                        <a:rPr lang="de-AT" dirty="0" err="1">
+                          <a:solidFill>
+                            <a:srgbClr val="F5F6FA"/>
+                          </a:solidFill>
+                          <a:effectLst/>
+                        </a:rPr>
+                        <a:t>Programming</a:t>
+                      </a:r>
+                      <a:endParaRPr lang="de-AT" dirty="0">
+                        <a:solidFill>
+                          <a:srgbClr val="F5F6FA"/>
+                        </a:solidFill>
+                        <a:effectLst/>
+                      </a:endParaRPr>
+                    </a:p>
+                  </a:txBody>
+                  <a:tcPr marL="22860" marR="22860" marT="0" marB="0" anchor="b">
+                    <a:lnL w="7620" cap="flat" cmpd="sng" algn="ctr">
+                      <a:solidFill>
+                        <a:srgbClr val="CCCCCC"/>
+                      </a:solidFill>
+                      <a:prstDash val="solid"/>
+                      <a:round/>
+                      <a:headEnd type="none" w="med" len="med"/>
+                      <a:tailEnd type="none" w="med" len="med"/>
+                    </a:lnL>
+                    <a:lnR w="7620" cap="flat" cmpd="sng" algn="ctr">
+                      <a:solidFill>
+                        <a:srgbClr val="CCCCCC"/>
+                      </a:solidFill>
+                      <a:prstDash val="solid"/>
+                      <a:round/>
+                      <a:headEnd type="none" w="med" len="med"/>
+                      <a:tailEnd type="none" w="med" len="med"/>
+                    </a:lnR>
+                    <a:lnT w="7620" cap="flat" cmpd="sng" algn="ctr">
+                      <a:solidFill>
+                        <a:srgbClr val="CCCCCC"/>
+                      </a:solidFill>
+                      <a:prstDash val="solid"/>
+                      <a:round/>
+                      <a:headEnd type="none" w="med" len="med"/>
+                      <a:tailEnd type="none" w="med" len="med"/>
+                    </a:lnT>
+                    <a:lnB w="7620" cap="flat" cmpd="sng" algn="ctr">
+                      <a:solidFill>
+                        <a:srgbClr val="CCCCCC"/>
+                      </a:solidFill>
+                      <a:prstDash val="solid"/>
+                      <a:round/>
+                      <a:headEnd type="none" w="med" len="med"/>
+                      <a:tailEnd type="none" w="med" len="med"/>
+                    </a:lnB>
+                    <a:noFill/>
+                  </a:tcPr>
+                </a:tc>
+                <a:tc>
+                  <a:txBody>
+                    <a:bodyPr/>
+                    <a:lstStyle/>
+                    <a:p>
+                      <a:pPr rtl="0" fontAlgn="b">
+                        <a:buNone/>
+                      </a:pPr>
+                      <a:endParaRPr lang="en-US" dirty="0">
+                        <a:solidFill>
+                          <a:srgbClr val="F5F6FA"/>
+                        </a:solidFill>
+                        <a:effectLst/>
+                      </a:endParaRPr>
+                    </a:p>
+                  </a:txBody>
+                  <a:tcPr marL="22860" marR="22860" marT="0" marB="0" anchor="b">
+                    <a:lnL w="7620" cap="flat" cmpd="sng" algn="ctr">
+                      <a:solidFill>
+                        <a:srgbClr val="CCCCCC"/>
+                      </a:solidFill>
+                      <a:prstDash val="solid"/>
+                      <a:round/>
+                      <a:headEnd type="none" w="med" len="med"/>
+                      <a:tailEnd type="none" w="med" len="med"/>
+                    </a:lnL>
+                    <a:lnR w="7620" cap="flat" cmpd="sng" algn="ctr">
+                      <a:solidFill>
+                        <a:srgbClr val="CCCCCC"/>
+                      </a:solidFill>
+                      <a:prstDash val="solid"/>
+                      <a:round/>
+                      <a:headEnd type="none" w="med" len="med"/>
+                      <a:tailEnd type="none" w="med" len="med"/>
+                    </a:lnR>
+                    <a:lnT w="7620" cap="flat" cmpd="sng" algn="ctr">
+                      <a:solidFill>
+                        <a:srgbClr val="CCCCCC"/>
+                      </a:solidFill>
+                      <a:prstDash val="solid"/>
+                      <a:round/>
+                      <a:headEnd type="none" w="med" len="med"/>
+                      <a:tailEnd type="none" w="med" len="med"/>
+                    </a:lnT>
+                    <a:lnB w="7620" cap="flat" cmpd="sng" algn="ctr">
+                      <a:solidFill>
+                        <a:srgbClr val="CCCCCC"/>
+                      </a:solidFill>
+                      <a:prstDash val="solid"/>
+                      <a:round/>
+                      <a:headEnd type="none" w="med" len="med"/>
+                      <a:tailEnd type="none" w="med" len="med"/>
+                    </a:lnB>
+                    <a:noFill/>
+                  </a:tcPr>
+                </a:tc>
+                <a:extLst>
+                  <a:ext uri="{0D108BD9-81ED-4DB2-BD59-A6C34878D82A}">
+                    <a16:rowId xmlns:a16="http://schemas.microsoft.com/office/drawing/2014/main" val="2922597159"/>
+                  </a:ext>
+                </a:extLst>
+              </a:tr>
+            </a:tbl>
+          </a:graphicData>
+        </a:graphic>
+      </p:graphicFrame>
+    </p:spTree>
+    <p:extLst>
+      <p:ext uri="{BB962C8B-B14F-4D97-AF65-F5344CB8AC3E}">
+        <p14:creationId xmlns:p14="http://schemas.microsoft.com/office/powerpoint/2010/main" val="729277477"/>
+      </p:ext>
+    </p:extLst>
+  </p:cSld>
+  <p:clrMapOvr>
+    <a:masterClrMapping/>
+  </p:clrMapOvr>
+</p:sld>
+</file>
+
+<file path=ppt/slides/slide11.xml><?xml version="1.0" encoding="utf-8"?>
+<p:sld xmlns:a="http://schemas.openxmlformats.org/drawingml/2006/main" xmlns:r="http://schemas.openxmlformats.org/officeDocument/2006/relationships" xmlns:p="http://schemas.openxmlformats.org/presentationml/2006/main">
+  <p:cSld>
+    <p:spTree>
+      <p:nvGrpSpPr>
+        <p:cNvPr id="1" name="">
+          <a:extLst>
+            <a:ext uri="{FF2B5EF4-FFF2-40B4-BE49-F238E27FC236}">
+              <a16:creationId xmlns:a16="http://schemas.microsoft.com/office/drawing/2014/main" id="{BFDAC7EC-8FB2-9176-BD76-CCA51A822C93}"/>
+            </a:ext>
+          </a:extLst>
+        </p:cNvPr>
+        <p:cNvGrpSpPr/>
+        <p:nvPr/>
+      </p:nvGrpSpPr>
+      <p:grpSpPr>
+        <a:xfrm>
+          <a:off x="0" y="0"/>
+          <a:ext cx="0" cy="0"/>
+          <a:chOff x="0" y="0"/>
+          <a:chExt cx="0" cy="0"/>
+        </a:xfrm>
+      </p:grpSpPr>
+      <p:sp>
+        <p:nvSpPr>
+          <p:cNvPr id="3" name="Textfeld 2">
+            <a:extLst>
+              <a:ext uri="{FF2B5EF4-FFF2-40B4-BE49-F238E27FC236}">
+                <a16:creationId xmlns:a16="http://schemas.microsoft.com/office/drawing/2014/main" id="{3CDEDE94-AF08-AD4F-E03B-50ABC8A1C578}"/>
+              </a:ext>
+            </a:extLst>
+          </p:cNvPr>
+          <p:cNvSpPr txBox="1"/>
+          <p:nvPr/>
+        </p:nvSpPr>
+        <p:spPr>
+          <a:xfrm>
+            <a:off x="931653" y="2798168"/>
+            <a:ext cx="8149805" cy="3338478"/>
+          </a:xfrm>
+          <a:prstGeom prst="rect">
+            <a:avLst/>
+          </a:prstGeom>
+          <a:noFill/>
+        </p:spPr>
+        <p:txBody>
+          <a:bodyPr wrap="square">
+            <a:spAutoFit/>
+          </a:bodyPr>
+          <a:lstStyle/>
+          <a:p>
+            <a:pPr>
+              <a:lnSpc>
+                <a:spcPts val="1425"/>
+              </a:lnSpc>
+              <a:buNone/>
+            </a:pPr>
+            <a:r>
+              <a:rPr lang="en-US" b="0" dirty="0">
+                <a:solidFill>
+                  <a:srgbClr val="CCCCCC"/>
+                </a:solidFill>
+                <a:effectLst/>
+                <a:latin typeface="Consolas" panose="020B0609020204030204" pitchFamily="49" charset="0"/>
+              </a:rPr>
+              <a:t>The following code defines </a:t>
+            </a:r>
+            <a:r>
+              <a:rPr lang="en-US" b="0" dirty="0">
+                <a:solidFill>
+                  <a:srgbClr val="CE9178"/>
+                </a:solidFill>
+                <a:effectLst/>
+                <a:latin typeface="Consolas" panose="020B0609020204030204" pitchFamily="49" charset="0"/>
+              </a:rPr>
+              <a:t>`</a:t>
+            </a:r>
+            <a:r>
+              <a:rPr lang="en-US" b="0" dirty="0" err="1">
+                <a:solidFill>
+                  <a:srgbClr val="CE9178"/>
+                </a:solidFill>
+                <a:effectLst/>
+                <a:latin typeface="Consolas" panose="020B0609020204030204" pitchFamily="49" charset="0"/>
+              </a:rPr>
+              <a:t>discover_data_files</a:t>
+            </a:r>
+            <a:r>
+              <a:rPr lang="en-US" b="0" dirty="0">
+                <a:solidFill>
+                  <a:srgbClr val="CE9178"/>
+                </a:solidFill>
+                <a:effectLst/>
+                <a:latin typeface="Consolas" panose="020B0609020204030204" pitchFamily="49" charset="0"/>
+              </a:rPr>
+              <a:t>()`</a:t>
+            </a:r>
+            <a:r>
+              <a:rPr lang="en-US" b="0" dirty="0">
+                <a:solidFill>
+                  <a:srgbClr val="CCCCCC"/>
+                </a:solidFill>
+                <a:effectLst/>
+                <a:latin typeface="Consolas" panose="020B0609020204030204" pitchFamily="49" charset="0"/>
+              </a:rPr>
+              <a:t> which discovers and saves the names and location of the data files to be ingested.</a:t>
+            </a:r>
+          </a:p>
+          <a:p>
+            <a:pPr>
+              <a:lnSpc>
+                <a:spcPts val="1425"/>
+              </a:lnSpc>
+              <a:buNone/>
+            </a:pPr>
+            <a:r>
+              <a:rPr lang="en-US" b="0" dirty="0">
+                <a:solidFill>
+                  <a:srgbClr val="CCCCCC"/>
+                </a:solidFill>
+                <a:effectLst/>
+                <a:latin typeface="Consolas" panose="020B0609020204030204" pitchFamily="49" charset="0"/>
+              </a:rPr>
+              <a:t>This function uses RAW_DATA_PATH paths given by </a:t>
+            </a:r>
+            <a:r>
+              <a:rPr lang="en-US" b="0" dirty="0">
+                <a:solidFill>
+                  <a:srgbClr val="CE9178"/>
+                </a:solidFill>
+                <a:effectLst/>
+                <a:latin typeface="Consolas" panose="020B0609020204030204" pitchFamily="49" charset="0"/>
+              </a:rPr>
+              <a:t>`</a:t>
+            </a:r>
+            <a:r>
+              <a:rPr lang="en-US" b="0" dirty="0" err="1">
+                <a:solidFill>
+                  <a:srgbClr val="CE9178"/>
+                </a:solidFill>
+                <a:effectLst/>
+                <a:latin typeface="Consolas" panose="020B0609020204030204" pitchFamily="49" charset="0"/>
+              </a:rPr>
+              <a:t>setup_project_paths</a:t>
+            </a:r>
+            <a:r>
+              <a:rPr lang="en-US" b="0" dirty="0">
+                <a:solidFill>
+                  <a:srgbClr val="CE9178"/>
+                </a:solidFill>
+                <a:effectLst/>
+                <a:latin typeface="Consolas" panose="020B0609020204030204" pitchFamily="49" charset="0"/>
+              </a:rPr>
+              <a:t>()`</a:t>
+            </a:r>
+            <a:r>
+              <a:rPr lang="en-US" b="0" dirty="0">
+                <a:solidFill>
+                  <a:srgbClr val="CCCCCC"/>
+                </a:solidFill>
+                <a:effectLst/>
+                <a:latin typeface="Consolas" panose="020B0609020204030204" pitchFamily="49" charset="0"/>
+              </a:rPr>
+              <a:t>. Additionally it can flexibly access </a:t>
+            </a:r>
+            <a:r>
+              <a:rPr lang="en-US" b="0" dirty="0" err="1">
+                <a:solidFill>
+                  <a:srgbClr val="CCCCCC"/>
+                </a:solidFill>
+                <a:effectLst/>
+                <a:latin typeface="Consolas" panose="020B0609020204030204" pitchFamily="49" charset="0"/>
+              </a:rPr>
+              <a:t>file_patterns</a:t>
+            </a:r>
+            <a:r>
+              <a:rPr lang="en-US" b="0" dirty="0">
+                <a:solidFill>
+                  <a:srgbClr val="CCCCCC"/>
+                </a:solidFill>
+                <a:effectLst/>
+                <a:latin typeface="Consolas" panose="020B0609020204030204" pitchFamily="49" charset="0"/>
+              </a:rPr>
+              <a:t> or access single years only and </a:t>
+            </a:r>
+          </a:p>
+          <a:p>
+            <a:pPr>
+              <a:lnSpc>
+                <a:spcPts val="1425"/>
+              </a:lnSpc>
+              <a:buNone/>
+            </a:pPr>
+            <a:br>
+              <a:rPr lang="en-US" b="0" dirty="0">
+                <a:solidFill>
+                  <a:srgbClr val="CCCCCC"/>
+                </a:solidFill>
+                <a:effectLst/>
+                <a:latin typeface="Consolas" panose="020B0609020204030204" pitchFamily="49" charset="0"/>
+              </a:rPr>
+            </a:br>
+            <a:endParaRPr lang="en-US" b="0" dirty="0">
+              <a:solidFill>
+                <a:srgbClr val="CCCCCC"/>
+              </a:solidFill>
+              <a:effectLst/>
+              <a:latin typeface="Consolas" panose="020B0609020204030204" pitchFamily="49" charset="0"/>
+            </a:endParaRPr>
+          </a:p>
+          <a:p>
+            <a:pPr>
+              <a:lnSpc>
+                <a:spcPts val="1425"/>
+              </a:lnSpc>
+              <a:buNone/>
+            </a:pPr>
+            <a:r>
+              <a:rPr lang="en-US" b="0" dirty="0">
+                <a:solidFill>
+                  <a:srgbClr val="CCCCCC"/>
+                </a:solidFill>
+                <a:effectLst/>
+                <a:latin typeface="Consolas" panose="020B0609020204030204" pitchFamily="49" charset="0"/>
+              </a:rPr>
+              <a:t>This function is necessary to allow this code to run on different machines or when the project folder is located in different locations on the same machine.</a:t>
+            </a:r>
+          </a:p>
+          <a:p>
+            <a:pPr>
+              <a:lnSpc>
+                <a:spcPts val="1425"/>
+              </a:lnSpc>
+              <a:buNone/>
+            </a:pPr>
+            <a:br>
+              <a:rPr lang="en-US" b="0" dirty="0">
+                <a:solidFill>
+                  <a:srgbClr val="CCCCCC"/>
+                </a:solidFill>
+                <a:effectLst/>
+                <a:latin typeface="Consolas" panose="020B0609020204030204" pitchFamily="49" charset="0"/>
+              </a:rPr>
+            </a:br>
+            <a:endParaRPr lang="en-US" b="0" dirty="0">
+              <a:solidFill>
+                <a:srgbClr val="CCCCCC"/>
+              </a:solidFill>
+              <a:effectLst/>
+              <a:latin typeface="Consolas" panose="020B0609020204030204" pitchFamily="49" charset="0"/>
+            </a:endParaRPr>
+          </a:p>
+          <a:p>
+            <a:pPr>
+              <a:lnSpc>
+                <a:spcPts val="1425"/>
+              </a:lnSpc>
+              <a:buNone/>
+            </a:pPr>
+            <a:r>
+              <a:rPr lang="en-US" b="0" dirty="0">
+                <a:solidFill>
+                  <a:srgbClr val="CCCCCC"/>
+                </a:solidFill>
+                <a:effectLst/>
+                <a:latin typeface="Consolas" panose="020B0609020204030204" pitchFamily="49" charset="0"/>
+              </a:rPr>
+              <a:t>Also this allows an unspecified number of files corresponding to the given name pattern to be loaded automatically, thus </a:t>
+            </a:r>
+            <a:r>
+              <a:rPr lang="en-US" b="0" dirty="0" err="1">
+                <a:solidFill>
+                  <a:srgbClr val="CCCCCC"/>
+                </a:solidFill>
+                <a:effectLst/>
+                <a:latin typeface="Consolas" panose="020B0609020204030204" pitchFamily="49" charset="0"/>
+              </a:rPr>
+              <a:t>future_proofing</a:t>
+            </a:r>
+            <a:r>
+              <a:rPr lang="en-US" b="0" dirty="0">
+                <a:solidFill>
+                  <a:srgbClr val="CCCCCC"/>
+                </a:solidFill>
+                <a:effectLst/>
+                <a:latin typeface="Consolas" panose="020B0609020204030204" pitchFamily="49" charset="0"/>
+              </a:rPr>
+              <a:t> the data pipeline for when files are changed or when additional files for years &lt;2015 or &gt;2025 become available. </a:t>
+            </a:r>
+          </a:p>
+        </p:txBody>
+      </p:sp>
+      <p:sp>
+        <p:nvSpPr>
+          <p:cNvPr id="5" name="Textfeld 4">
+            <a:extLst>
+              <a:ext uri="{FF2B5EF4-FFF2-40B4-BE49-F238E27FC236}">
+                <a16:creationId xmlns:a16="http://schemas.microsoft.com/office/drawing/2014/main" id="{392A8A03-C6B0-AC7D-E33C-B9A3FFDACDF8}"/>
+              </a:ext>
+            </a:extLst>
+          </p:cNvPr>
+          <p:cNvSpPr txBox="1"/>
+          <p:nvPr/>
+        </p:nvSpPr>
+        <p:spPr>
+          <a:xfrm>
+            <a:off x="1240046" y="500332"/>
+            <a:ext cx="7737895" cy="369332"/>
+          </a:xfrm>
+          <a:prstGeom prst="rect">
+            <a:avLst/>
+          </a:prstGeom>
+          <a:noFill/>
+        </p:spPr>
+        <p:txBody>
+          <a:bodyPr wrap="square" rtlCol="0">
+            <a:spAutoFit/>
+          </a:bodyPr>
+          <a:lstStyle/>
+          <a:p>
+            <a:r>
+              <a:rPr lang="de-AT" dirty="0"/>
+              <a:t>Case </a:t>
+            </a:r>
+            <a:r>
+              <a:rPr lang="de-AT" dirty="0" err="1"/>
+              <a:t>study</a:t>
+            </a:r>
+            <a:r>
+              <a:rPr lang="de-AT" dirty="0"/>
+              <a:t>: Future </a:t>
+            </a:r>
+            <a:r>
+              <a:rPr lang="de-AT" dirty="0" err="1"/>
+              <a:t>proofing</a:t>
+            </a:r>
+            <a:r>
+              <a:rPr lang="de-AT" dirty="0"/>
+              <a:t>. </a:t>
+            </a:r>
+            <a:r>
+              <a:rPr lang="de-AT" dirty="0" err="1"/>
+              <a:t>Why</a:t>
+            </a:r>
+            <a:r>
+              <a:rPr lang="de-AT" dirty="0"/>
+              <a:t> </a:t>
+            </a:r>
+            <a:r>
+              <a:rPr lang="en-US" dirty="0">
+                <a:solidFill>
+                  <a:srgbClr val="CE9178"/>
+                </a:solidFill>
+                <a:latin typeface="Consolas" panose="020B0609020204030204" pitchFamily="49" charset="0"/>
+              </a:rPr>
+              <a:t>`</a:t>
+            </a:r>
+            <a:r>
+              <a:rPr lang="en-US" dirty="0" err="1">
+                <a:solidFill>
+                  <a:srgbClr val="CE9178"/>
+                </a:solidFill>
+                <a:latin typeface="Consolas" panose="020B0609020204030204" pitchFamily="49" charset="0"/>
+              </a:rPr>
+              <a:t>discover_data_files</a:t>
+            </a:r>
+            <a:r>
+              <a:rPr lang="en-US" dirty="0">
+                <a:solidFill>
+                  <a:srgbClr val="CE9178"/>
+                </a:solidFill>
+                <a:latin typeface="Consolas" panose="020B0609020204030204" pitchFamily="49" charset="0"/>
+              </a:rPr>
+              <a:t>()`? </a:t>
+            </a:r>
+            <a:r>
+              <a:rPr lang="en-US" dirty="0">
+                <a:solidFill>
+                  <a:srgbClr val="CCCCCC"/>
+                </a:solidFill>
+                <a:latin typeface="Consolas" panose="020B0609020204030204" pitchFamily="49" charset="0"/>
+              </a:rPr>
+              <a:t> </a:t>
+            </a:r>
+            <a:endParaRPr lang="de-AT" dirty="0"/>
+          </a:p>
+        </p:txBody>
+      </p:sp>
+      <p:sp>
+        <p:nvSpPr>
+          <p:cNvPr id="6" name="Textfeld 5">
+            <a:extLst>
+              <a:ext uri="{FF2B5EF4-FFF2-40B4-BE49-F238E27FC236}">
+                <a16:creationId xmlns:a16="http://schemas.microsoft.com/office/drawing/2014/main" id="{E0D9D6D2-D624-4F88-6AE4-D47BD15A969D}"/>
+              </a:ext>
+            </a:extLst>
+          </p:cNvPr>
+          <p:cNvSpPr txBox="1"/>
+          <p:nvPr/>
+        </p:nvSpPr>
+        <p:spPr>
+          <a:xfrm>
+            <a:off x="1004258" y="1662023"/>
+            <a:ext cx="7737895" cy="923330"/>
+          </a:xfrm>
+          <a:prstGeom prst="rect">
+            <a:avLst/>
+          </a:prstGeom>
+          <a:noFill/>
+        </p:spPr>
+        <p:txBody>
+          <a:bodyPr wrap="square" rtlCol="0">
+            <a:spAutoFit/>
+          </a:bodyPr>
+          <a:lstStyle/>
+          <a:p>
+            <a:r>
+              <a:rPr lang="de-AT" dirty="0"/>
+              <a:t>Use Case: </a:t>
+            </a:r>
+          </a:p>
+          <a:p>
+            <a:r>
+              <a:rPr lang="de-AT" dirty="0"/>
+              <a:t>The </a:t>
+            </a:r>
+            <a:r>
+              <a:rPr lang="de-AT" dirty="0" err="1"/>
+              <a:t>data</a:t>
+            </a:r>
+            <a:r>
+              <a:rPr lang="de-AT" dirty="0"/>
+              <a:t> </a:t>
+            </a:r>
+            <a:r>
+              <a:rPr lang="de-AT" dirty="0" err="1"/>
+              <a:t>used</a:t>
+            </a:r>
+            <a:r>
+              <a:rPr lang="de-AT" dirty="0"/>
+              <a:t> for </a:t>
+            </a:r>
+            <a:r>
+              <a:rPr lang="de-AT" dirty="0" err="1"/>
+              <a:t>prediction</a:t>
+            </a:r>
+            <a:r>
+              <a:rPr lang="de-AT" dirty="0"/>
+              <a:t> </a:t>
+            </a:r>
+            <a:r>
+              <a:rPr lang="de-AT" dirty="0" err="1"/>
+              <a:t>may</a:t>
+            </a:r>
+            <a:r>
+              <a:rPr lang="de-AT" dirty="0"/>
+              <a:t> </a:t>
+            </a:r>
+            <a:r>
+              <a:rPr lang="de-AT" dirty="0" err="1"/>
+              <a:t>change</a:t>
+            </a:r>
+            <a:r>
+              <a:rPr lang="de-AT" dirty="0"/>
+              <a:t>. Additional </a:t>
+            </a:r>
+            <a:r>
+              <a:rPr lang="de-AT" dirty="0" err="1"/>
+              <a:t>files</a:t>
+            </a:r>
+            <a:r>
+              <a:rPr lang="de-AT" dirty="0"/>
+              <a:t> </a:t>
+            </a:r>
+            <a:r>
+              <a:rPr lang="de-AT" dirty="0" err="1"/>
+              <a:t>may</a:t>
+            </a:r>
+            <a:r>
+              <a:rPr lang="de-AT" dirty="0"/>
+              <a:t> </a:t>
+            </a:r>
+            <a:r>
+              <a:rPr lang="de-AT" dirty="0" err="1"/>
+              <a:t>become</a:t>
+            </a:r>
+            <a:r>
+              <a:rPr lang="de-AT" dirty="0"/>
+              <a:t> </a:t>
+            </a:r>
+            <a:r>
+              <a:rPr lang="de-AT" dirty="0" err="1"/>
+              <a:t>available</a:t>
+            </a:r>
+            <a:r>
+              <a:rPr lang="de-AT" dirty="0"/>
+              <a:t>, </a:t>
+            </a:r>
+            <a:r>
+              <a:rPr lang="de-AT" dirty="0" err="1"/>
+              <a:t>or</a:t>
+            </a:r>
+            <a:r>
+              <a:rPr lang="de-AT" dirty="0"/>
+              <a:t> </a:t>
+            </a:r>
+            <a:r>
+              <a:rPr lang="de-AT" dirty="0" err="1"/>
+              <a:t>existing</a:t>
+            </a:r>
+            <a:r>
+              <a:rPr lang="de-AT" dirty="0"/>
+              <a:t> </a:t>
+            </a:r>
+            <a:r>
+              <a:rPr lang="de-AT" dirty="0" err="1"/>
+              <a:t>files</a:t>
+            </a:r>
+            <a:r>
+              <a:rPr lang="de-AT" dirty="0"/>
+              <a:t> </a:t>
+            </a:r>
+            <a:r>
+              <a:rPr lang="de-AT" dirty="0" err="1"/>
+              <a:t>may</a:t>
+            </a:r>
+            <a:r>
+              <a:rPr lang="de-AT" dirty="0"/>
+              <a:t> </a:t>
+            </a:r>
+            <a:r>
+              <a:rPr lang="de-AT" dirty="0" err="1"/>
+              <a:t>change</a:t>
+            </a:r>
+            <a:r>
+              <a:rPr lang="de-AT" dirty="0"/>
+              <a:t>.</a:t>
+            </a:r>
+          </a:p>
+        </p:txBody>
+      </p:sp>
+    </p:spTree>
+    <p:extLst>
+      <p:ext uri="{BB962C8B-B14F-4D97-AF65-F5344CB8AC3E}">
+        <p14:creationId xmlns:p14="http://schemas.microsoft.com/office/powerpoint/2010/main" val="3736530436"/>
+      </p:ext>
+    </p:extLst>
+  </p:cSld>
+  <p:clrMapOvr>
+    <a:masterClrMapping/>
+  </p:clrMapOvr>
+</p:sld>
+</file>
+
+<file path=ppt/slides/slide12.xml><?xml version="1.0" encoding="utf-8"?>
+<p:sld xmlns:a="http://schemas.openxmlformats.org/drawingml/2006/main" xmlns:r="http://schemas.openxmlformats.org/officeDocument/2006/relationships" xmlns:p="http://schemas.openxmlformats.org/presentationml/2006/main">
+  <p:cSld>
+    <p:spTree>
+      <p:nvGrpSpPr>
+        <p:cNvPr id="1" name="">
+          <a:extLst>
+            <a:ext uri="{FF2B5EF4-FFF2-40B4-BE49-F238E27FC236}">
+              <a16:creationId xmlns:a16="http://schemas.microsoft.com/office/drawing/2014/main" id="{2C665BA4-6E50-90B0-A4B9-3F17B66EACA5}"/>
+            </a:ext>
+          </a:extLst>
+        </p:cNvPr>
+        <p:cNvGrpSpPr/>
+        <p:nvPr/>
+      </p:nvGrpSpPr>
+      <p:grpSpPr>
+        <a:xfrm>
+          <a:off x="0" y="0"/>
+          <a:ext cx="0" cy="0"/>
+          <a:chOff x="0" y="0"/>
+          <a:chExt cx="0" cy="0"/>
+        </a:xfrm>
+      </p:grpSpPr>
+      <p:graphicFrame>
+        <p:nvGraphicFramePr>
+          <p:cNvPr id="4" name="Tabelle 3">
+            <a:extLst>
+              <a:ext uri="{FF2B5EF4-FFF2-40B4-BE49-F238E27FC236}">
+                <a16:creationId xmlns:a16="http://schemas.microsoft.com/office/drawing/2014/main" id="{1338122B-1996-714F-9E15-D1797EED24BF}"/>
+              </a:ext>
+            </a:extLst>
+          </p:cNvPr>
+          <p:cNvGraphicFramePr>
+            <a:graphicFrameLocks noGrp="1"/>
+          </p:cNvGraphicFramePr>
           <p:nvPr/>
         </p:nvGraphicFramePr>
         <p:xfrm>
@@ -4222,11 +6026,20 @@
                         <a:buNone/>
                       </a:pPr>
                       <a:r>
-                        <a:rPr lang="de-AT">
+                        <a:rPr lang="de-AT" dirty="0">
                           <a:effectLst/>
                         </a:rPr>
-                        <a:t>Communication: Writing &amp; Presentation</a:t>
+                        <a:t>Communication: Writing &amp; </a:t>
                       </a:r>
+                      <a:r>
+                        <a:rPr lang="de-AT" dirty="0" err="1">
+                          <a:effectLst/>
+                        </a:rPr>
+                        <a:t>Presentation</a:t>
+                      </a:r>
+                      <a:endParaRPr lang="de-AT" dirty="0">
+                        <a:effectLst/>
+                      </a:endParaRPr>
                     </a:p>
                   </a:txBody>
                   <a:tcPr marL="22860" marR="22860" marT="0" marB="0" anchor="b">
@@ -4338,10 +6151,22 @@
                         <a:buNone/>
                       </a:pPr>
                       <a:r>
-                        <a:rPr lang="de-AT">
+                        <a:rPr lang="de-AT" dirty="0">
                           <a:effectLst/>
                         </a:rPr>
-                        <a:t>EDA: Data Visualization &amp; Exploration</a:t>
+                        <a:t>EDA: Data </a:t>
+                      </a:r>
+                      <a:r>
+                        <a:rPr lang="de-AT" dirty="0" err="1">
+                          <a:effectLst/>
+                        </a:rPr>
+                        <a:t>Visualization</a:t>
+                      </a:r>
+                      <a:r>
+                        <a:rPr lang="de-AT" dirty="0">
+                          <a:effectLst/>
+                        </a:rPr>
+                        <a:t> &amp; Exploration</a:t>
                       </a:r>
                     </a:p>
                   </a:txBody>
@@ -4454,11 +6279,20 @@
                         <a:buNone/>
                       </a:pPr>
                       <a:r>
-                        <a:rPr lang="de-AT">
+                        <a:rPr lang="de-AT" dirty="0">
                           <a:effectLst/>
                         </a:rPr>
-                        <a:t>Modeling / Statistics</a:t>
+                        <a:t>Modeling / </a:t>
                       </a:r>
+                      <a:r>
+                        <a:rPr lang="de-AT" dirty="0" err="1">
+                          <a:effectLst/>
+                        </a:rPr>
+                        <a:t>Statistics</a:t>
+                      </a:r>
+                      <a:endParaRPr lang="de-AT" dirty="0">
+                        <a:effectLst/>
+                      </a:endParaRPr>
                     </a:p>
                   </a:txBody>
                   <a:tcPr marL="22860" marR="22860" marT="0" marB="0" anchor="b">
@@ -4683,561 +6517,7 @@
     </p:spTree>
     <p:extLst>
       <p:ext uri="{BB962C8B-B14F-4D97-AF65-F5344CB8AC3E}">
-        <p14:creationId xmlns:p14="http://schemas.microsoft.com/office/powerpoint/2010/main" val="729277477"/>
-      </p:ext>
-    </p:extLst>
-  </p:cSld>
-  <p:clrMapOvr>
-    <a:masterClrMapping/>
-  </p:clrMapOvr>
-</p:sld>
-</file>
-
-<file path=ppt/slides/slide11.xml><?xml version="1.0" encoding="utf-8"?>
-<p:sld xmlns:a="http://schemas.openxmlformats.org/drawingml/2006/main" xmlns:r="http://schemas.openxmlformats.org/officeDocument/2006/relationships" xmlns:p="http://schemas.openxmlformats.org/presentationml/2006/main">
-  <p:cSld>
-    <p:spTree>
-      <p:nvGrpSpPr>
-        <p:cNvPr id="1" name="">
-          <a:extLst>
-            <a:ext uri="{FF2B5EF4-FFF2-40B4-BE49-F238E27FC236}">
-              <a16:creationId xmlns:a16="http://schemas.microsoft.com/office/drawing/2014/main" id="{BFDAC7EC-8FB2-9176-BD76-CCA51A822C93}"/>
-            </a:ext>
-          </a:extLst>
-        </p:cNvPr>
-        <p:cNvGrpSpPr/>
-        <p:nvPr/>
-      </p:nvGrpSpPr>
-      <p:grpSpPr>
-        <a:xfrm>
-          <a:off x="0" y="0"/>
-          <a:ext cx="0" cy="0"/>
-          <a:chOff x="0" y="0"/>
-          <a:chExt cx="0" cy="0"/>
-        </a:xfrm>
-      </p:grpSpPr>
-      <p:sp>
-        <p:nvSpPr>
-          <p:cNvPr id="3" name="Textfeld 2">
-            <a:extLst>
-              <a:ext uri="{FF2B5EF4-FFF2-40B4-BE49-F238E27FC236}">
-                <a16:creationId xmlns:a16="http://schemas.microsoft.com/office/drawing/2014/main" id="{3CDEDE94-AF08-AD4F-E03B-50ABC8A1C578}"/>
-              </a:ext>
-            </a:extLst>
-          </p:cNvPr>
-          <p:cNvSpPr txBox="1"/>
-          <p:nvPr/>
-        </p:nvSpPr>
-        <p:spPr>
-          <a:xfrm>
-            <a:off x="931653" y="2798168"/>
-            <a:ext cx="8149805" cy="3338478"/>
-          </a:xfrm>
-          <a:prstGeom prst="rect">
-            <a:avLst/>
-          </a:prstGeom>
-          <a:noFill/>
-        </p:spPr>
-        <p:txBody>
-          <a:bodyPr wrap="square">
-            <a:spAutoFit/>
-          </a:bodyPr>
-          <a:lstStyle/>
-          <a:p>
-            <a:pPr>
-              <a:lnSpc>
-                <a:spcPts val="1425"/>
-              </a:lnSpc>
-              <a:buNone/>
-            </a:pPr>
-            <a:r>
-              <a:rPr lang="en-US" b="0" dirty="0">
-                <a:solidFill>
-                  <a:srgbClr val="CCCCCC"/>
-                </a:solidFill>
-                <a:effectLst/>
-                <a:latin typeface="Consolas" panose="020B0609020204030204" pitchFamily="49" charset="0"/>
-              </a:rPr>
-              <a:t>The following code defines </a:t>
-            </a:r>
-            <a:r>
-              <a:rPr lang="en-US" b="0" dirty="0">
-                <a:solidFill>
-                  <a:srgbClr val="CE9178"/>
-                </a:solidFill>
-                <a:effectLst/>
-                <a:latin typeface="Consolas" panose="020B0609020204030204" pitchFamily="49" charset="0"/>
-              </a:rPr>
-              <a:t>`</a:t>
-            </a:r>
-            <a:r>
-              <a:rPr lang="en-US" b="0" dirty="0" err="1">
-                <a:solidFill>
-                  <a:srgbClr val="CE9178"/>
-                </a:solidFill>
-                <a:effectLst/>
-                <a:latin typeface="Consolas" panose="020B0609020204030204" pitchFamily="49" charset="0"/>
-              </a:rPr>
-              <a:t>discover_data_files</a:t>
-            </a:r>
-            <a:r>
-              <a:rPr lang="en-US" b="0" dirty="0">
-                <a:solidFill>
-                  <a:srgbClr val="CE9178"/>
-                </a:solidFill>
-                <a:effectLst/>
-                <a:latin typeface="Consolas" panose="020B0609020204030204" pitchFamily="49" charset="0"/>
-              </a:rPr>
-              <a:t>()`</a:t>
-            </a:r>
-            <a:r>
-              <a:rPr lang="en-US" b="0" dirty="0">
-                <a:solidFill>
-                  <a:srgbClr val="CCCCCC"/>
-                </a:solidFill>
-                <a:effectLst/>
-                <a:latin typeface="Consolas" panose="020B0609020204030204" pitchFamily="49" charset="0"/>
-              </a:rPr>
-              <a:t> which discovers and saves the names and location of the data files to be ingested.</a:t>
-            </a:r>
-          </a:p>
-          <a:p>
-            <a:pPr>
-              <a:lnSpc>
-                <a:spcPts val="1425"/>
-              </a:lnSpc>
-              <a:buNone/>
-            </a:pPr>
-            <a:r>
-              <a:rPr lang="en-US" b="0" dirty="0">
-                <a:solidFill>
-                  <a:srgbClr val="CCCCCC"/>
-                </a:solidFill>
-                <a:effectLst/>
-                <a:latin typeface="Consolas" panose="020B0609020204030204" pitchFamily="49" charset="0"/>
-              </a:rPr>
-              <a:t>This function uses RAW_DATA_PATH paths given by </a:t>
-            </a:r>
-            <a:r>
-              <a:rPr lang="en-US" b="0" dirty="0">
-                <a:solidFill>
-                  <a:srgbClr val="CE9178"/>
-                </a:solidFill>
-                <a:effectLst/>
-                <a:latin typeface="Consolas" panose="020B0609020204030204" pitchFamily="49" charset="0"/>
-              </a:rPr>
-              <a:t>`</a:t>
-            </a:r>
-            <a:r>
-              <a:rPr lang="en-US" b="0" dirty="0" err="1">
-                <a:solidFill>
-                  <a:srgbClr val="CE9178"/>
-                </a:solidFill>
-                <a:effectLst/>
-                <a:latin typeface="Consolas" panose="020B0609020204030204" pitchFamily="49" charset="0"/>
-              </a:rPr>
-              <a:t>setup_project_paths</a:t>
-            </a:r>
-            <a:r>
-              <a:rPr lang="en-US" b="0" dirty="0">
-                <a:solidFill>
-                  <a:srgbClr val="CE9178"/>
-                </a:solidFill>
-                <a:effectLst/>
-                <a:latin typeface="Consolas" panose="020B0609020204030204" pitchFamily="49" charset="0"/>
-              </a:rPr>
-              <a:t>()`</a:t>
-            </a:r>
-            <a:r>
-              <a:rPr lang="en-US" b="0" dirty="0">
-                <a:solidFill>
-                  <a:srgbClr val="CCCCCC"/>
-                </a:solidFill>
-                <a:effectLst/>
-                <a:latin typeface="Consolas" panose="020B0609020204030204" pitchFamily="49" charset="0"/>
-              </a:rPr>
-              <a:t>. Additionally it can flexibly access </a:t>
-            </a:r>
-            <a:r>
-              <a:rPr lang="en-US" b="0" dirty="0" err="1">
-                <a:solidFill>
-                  <a:srgbClr val="CCCCCC"/>
-                </a:solidFill>
-                <a:effectLst/>
-                <a:latin typeface="Consolas" panose="020B0609020204030204" pitchFamily="49" charset="0"/>
-              </a:rPr>
-              <a:t>file_patterns</a:t>
-            </a:r>
-            <a:r>
-              <a:rPr lang="en-US" b="0" dirty="0">
-                <a:solidFill>
-                  <a:srgbClr val="CCCCCC"/>
-                </a:solidFill>
-                <a:effectLst/>
-                <a:latin typeface="Consolas" panose="020B0609020204030204" pitchFamily="49" charset="0"/>
-              </a:rPr>
-              <a:t> or access single years only and </a:t>
-            </a:r>
-          </a:p>
-          <a:p>
-            <a:pPr>
-              <a:lnSpc>
-                <a:spcPts val="1425"/>
-              </a:lnSpc>
-              <a:buNone/>
-            </a:pPr>
-            <a:br>
-              <a:rPr lang="en-US" b="0" dirty="0">
-                <a:solidFill>
-                  <a:srgbClr val="CCCCCC"/>
-                </a:solidFill>
-                <a:effectLst/>
-                <a:latin typeface="Consolas" panose="020B0609020204030204" pitchFamily="49" charset="0"/>
-              </a:rPr>
-            </a:br>
-            <a:endParaRPr lang="en-US" b="0" dirty="0">
-              <a:solidFill>
-                <a:srgbClr val="CCCCCC"/>
-              </a:solidFill>
-              <a:effectLst/>
-              <a:latin typeface="Consolas" panose="020B0609020204030204" pitchFamily="49" charset="0"/>
-            </a:endParaRPr>
-          </a:p>
-          <a:p>
-            <a:pPr>
-              <a:lnSpc>
-                <a:spcPts val="1425"/>
-              </a:lnSpc>
-              <a:buNone/>
-            </a:pPr>
-            <a:r>
-              <a:rPr lang="en-US" b="0" dirty="0">
-                <a:solidFill>
-                  <a:srgbClr val="CCCCCC"/>
-                </a:solidFill>
-                <a:effectLst/>
-                <a:latin typeface="Consolas" panose="020B0609020204030204" pitchFamily="49" charset="0"/>
-              </a:rPr>
-              <a:t>This function is necessary to allow this code to run on different machines or when the project folder is located in different locations on the same machine.</a:t>
-            </a:r>
-          </a:p>
-          <a:p>
-            <a:pPr>
-              <a:lnSpc>
-                <a:spcPts val="1425"/>
-              </a:lnSpc>
-              <a:buNone/>
-            </a:pPr>
-            <a:br>
-              <a:rPr lang="en-US" b="0" dirty="0">
-                <a:solidFill>
-                  <a:srgbClr val="CCCCCC"/>
-                </a:solidFill>
-                <a:effectLst/>
-                <a:latin typeface="Consolas" panose="020B0609020204030204" pitchFamily="49" charset="0"/>
-              </a:rPr>
-            </a:br>
-            <a:endParaRPr lang="en-US" b="0" dirty="0">
-              <a:solidFill>
-                <a:srgbClr val="CCCCCC"/>
-              </a:solidFill>
-              <a:effectLst/>
-              <a:latin typeface="Consolas" panose="020B0609020204030204" pitchFamily="49" charset="0"/>
-            </a:endParaRPr>
-          </a:p>
-          <a:p>
-            <a:pPr>
-              <a:lnSpc>
-                <a:spcPts val="1425"/>
-              </a:lnSpc>
-              <a:buNone/>
-            </a:pPr>
-            <a:r>
-              <a:rPr lang="en-US" b="0" dirty="0">
-                <a:solidFill>
-                  <a:srgbClr val="CCCCCC"/>
-                </a:solidFill>
-                <a:effectLst/>
-                <a:latin typeface="Consolas" panose="020B0609020204030204" pitchFamily="49" charset="0"/>
-              </a:rPr>
-              <a:t>Also this allows an unspecified number of files corresponding to the given name pattern to be loaded automatically, thus </a:t>
-            </a:r>
-            <a:r>
-              <a:rPr lang="en-US" b="0" dirty="0" err="1">
-                <a:solidFill>
-                  <a:srgbClr val="CCCCCC"/>
-                </a:solidFill>
-                <a:effectLst/>
-                <a:latin typeface="Consolas" panose="020B0609020204030204" pitchFamily="49" charset="0"/>
-              </a:rPr>
-              <a:t>future_proofing</a:t>
-            </a:r>
-            <a:r>
-              <a:rPr lang="en-US" b="0" dirty="0">
-                <a:solidFill>
-                  <a:srgbClr val="CCCCCC"/>
-                </a:solidFill>
-                <a:effectLst/>
-                <a:latin typeface="Consolas" panose="020B0609020204030204" pitchFamily="49" charset="0"/>
-              </a:rPr>
-              <a:t> the data pipeline for when files are changed or when additional files for years &lt;2015 or &gt;2025 become available. </a:t>
-            </a:r>
-          </a:p>
-        </p:txBody>
-      </p:sp>
-      <p:sp>
-        <p:nvSpPr>
-          <p:cNvPr id="5" name="Textfeld 4">
-            <a:extLst>
-              <a:ext uri="{FF2B5EF4-FFF2-40B4-BE49-F238E27FC236}">
-                <a16:creationId xmlns:a16="http://schemas.microsoft.com/office/drawing/2014/main" id="{392A8A03-C6B0-AC7D-E33C-B9A3FFDACDF8}"/>
-              </a:ext>
-            </a:extLst>
-          </p:cNvPr>
-          <p:cNvSpPr txBox="1"/>
-          <p:nvPr/>
-        </p:nvSpPr>
-        <p:spPr>
-          <a:xfrm>
-            <a:off x="1240046" y="500332"/>
-            <a:ext cx="7737895" cy="369332"/>
-          </a:xfrm>
-          <a:prstGeom prst="rect">
-            <a:avLst/>
-          </a:prstGeom>
-          <a:noFill/>
-        </p:spPr>
-        <p:txBody>
-          <a:bodyPr wrap="square" rtlCol="0">
-            <a:spAutoFit/>
-          </a:bodyPr>
-          <a:lstStyle/>
-          <a:p>
-            <a:r>
-              <a:rPr lang="de-AT" dirty="0"/>
-              <a:t>Case </a:t>
-            </a:r>
-            <a:r>
-              <a:rPr lang="de-AT" dirty="0" err="1"/>
-              <a:t>study</a:t>
-            </a:r>
-            <a:r>
-              <a:rPr lang="de-AT" dirty="0"/>
-              <a:t>: Future </a:t>
-            </a:r>
-            <a:r>
-              <a:rPr lang="de-AT" dirty="0" err="1"/>
-              <a:t>proofing</a:t>
-            </a:r>
-            <a:r>
-              <a:rPr lang="de-AT" dirty="0"/>
-              <a:t>. </a:t>
-            </a:r>
-            <a:r>
-              <a:rPr lang="de-AT" dirty="0" err="1"/>
-              <a:t>Why</a:t>
-            </a:r>
-            <a:r>
-              <a:rPr lang="de-AT" dirty="0"/>
-              <a:t> </a:t>
-            </a:r>
-            <a:r>
-              <a:rPr lang="en-US" dirty="0">
-                <a:solidFill>
-                  <a:srgbClr val="CE9178"/>
-                </a:solidFill>
-                <a:latin typeface="Consolas" panose="020B0609020204030204" pitchFamily="49" charset="0"/>
-              </a:rPr>
-              <a:t>`</a:t>
-            </a:r>
-            <a:r>
-              <a:rPr lang="en-US" dirty="0" err="1">
-                <a:solidFill>
-                  <a:srgbClr val="CE9178"/>
-                </a:solidFill>
-                <a:latin typeface="Consolas" panose="020B0609020204030204" pitchFamily="49" charset="0"/>
-              </a:rPr>
-              <a:t>discover_data_files</a:t>
-            </a:r>
-            <a:r>
-              <a:rPr lang="en-US" dirty="0">
-                <a:solidFill>
-                  <a:srgbClr val="CE9178"/>
-                </a:solidFill>
-                <a:latin typeface="Consolas" panose="020B0609020204030204" pitchFamily="49" charset="0"/>
-              </a:rPr>
-              <a:t>()`? </a:t>
-            </a:r>
-            <a:r>
-              <a:rPr lang="en-US" dirty="0">
-                <a:solidFill>
-                  <a:srgbClr val="CCCCCC"/>
-                </a:solidFill>
-                <a:latin typeface="Consolas" panose="020B0609020204030204" pitchFamily="49" charset="0"/>
-              </a:rPr>
-              <a:t> </a:t>
-            </a:r>
-            <a:endParaRPr lang="de-AT" dirty="0"/>
-          </a:p>
-        </p:txBody>
-      </p:sp>
-      <p:sp>
-        <p:nvSpPr>
-          <p:cNvPr id="6" name="Textfeld 5">
-            <a:extLst>
-              <a:ext uri="{FF2B5EF4-FFF2-40B4-BE49-F238E27FC236}">
-                <a16:creationId xmlns:a16="http://schemas.microsoft.com/office/drawing/2014/main" id="{E0D9D6D2-D624-4F88-6AE4-D47BD15A969D}"/>
-              </a:ext>
-            </a:extLst>
-          </p:cNvPr>
-          <p:cNvSpPr txBox="1"/>
-          <p:nvPr/>
-        </p:nvSpPr>
-        <p:spPr>
-          <a:xfrm>
-            <a:off x="1004258" y="1662023"/>
-            <a:ext cx="7737895" cy="923330"/>
-          </a:xfrm>
-          <a:prstGeom prst="rect">
-            <a:avLst/>
-          </a:prstGeom>
-          <a:noFill/>
-        </p:spPr>
-        <p:txBody>
-          <a:bodyPr wrap="square" rtlCol="0">
-            <a:spAutoFit/>
-          </a:bodyPr>
-          <a:lstStyle/>
-          <a:p>
-            <a:r>
-              <a:rPr lang="de-AT" dirty="0"/>
-              <a:t>Use Case: </a:t>
-            </a:r>
-          </a:p>
-          <a:p>
-            <a:r>
-              <a:rPr lang="de-AT" dirty="0"/>
-              <a:t>The </a:t>
-            </a:r>
-            <a:r>
-              <a:rPr lang="de-AT" dirty="0" err="1"/>
-              <a:t>data</a:t>
-            </a:r>
-            <a:r>
-              <a:rPr lang="de-AT" dirty="0"/>
-              <a:t> </a:t>
-            </a:r>
-            <a:r>
-              <a:rPr lang="de-AT" dirty="0" err="1"/>
-              <a:t>used</a:t>
-            </a:r>
-            <a:r>
-              <a:rPr lang="de-AT" dirty="0"/>
-              <a:t> for </a:t>
-            </a:r>
-            <a:r>
-              <a:rPr lang="de-AT" dirty="0" err="1"/>
-              <a:t>prediction</a:t>
-            </a:r>
-            <a:r>
-              <a:rPr lang="de-AT" dirty="0"/>
-              <a:t> </a:t>
-            </a:r>
-            <a:r>
-              <a:rPr lang="de-AT" dirty="0" err="1"/>
-              <a:t>may</a:t>
-            </a:r>
-            <a:r>
-              <a:rPr lang="de-AT" dirty="0"/>
-              <a:t> </a:t>
-            </a:r>
-            <a:r>
-              <a:rPr lang="de-AT" dirty="0" err="1"/>
-              <a:t>change</a:t>
-            </a:r>
-            <a:r>
-              <a:rPr lang="de-AT" dirty="0"/>
-              <a:t>. Additional </a:t>
-            </a:r>
-            <a:r>
-              <a:rPr lang="de-AT" dirty="0" err="1"/>
-              <a:t>files</a:t>
-            </a:r>
-            <a:r>
-              <a:rPr lang="de-AT" dirty="0"/>
-              <a:t> </a:t>
-            </a:r>
-            <a:r>
-              <a:rPr lang="de-AT" dirty="0" err="1"/>
-              <a:t>may</a:t>
-            </a:r>
-            <a:r>
-              <a:rPr lang="de-AT" dirty="0"/>
-              <a:t> </a:t>
-            </a:r>
-            <a:r>
-              <a:rPr lang="de-AT" dirty="0" err="1"/>
-              <a:t>become</a:t>
-            </a:r>
-            <a:r>
-              <a:rPr lang="de-AT" dirty="0"/>
-              <a:t> </a:t>
-            </a:r>
-            <a:r>
-              <a:rPr lang="de-AT" dirty="0" err="1"/>
-              <a:t>available</a:t>
-            </a:r>
-            <a:r>
-              <a:rPr lang="de-AT" dirty="0"/>
-              <a:t>, </a:t>
-            </a:r>
-            <a:r>
-              <a:rPr lang="de-AT" dirty="0" err="1"/>
-              <a:t>or</a:t>
-            </a:r>
-            <a:r>
-              <a:rPr lang="de-AT" dirty="0"/>
-              <a:t> </a:t>
-            </a:r>
-            <a:r>
-              <a:rPr lang="de-AT" dirty="0" err="1"/>
-              <a:t>existing</a:t>
-            </a:r>
-            <a:r>
-              <a:rPr lang="de-AT" dirty="0"/>
-              <a:t> </a:t>
-            </a:r>
-            <a:r>
-              <a:rPr lang="de-AT" dirty="0" err="1"/>
-              <a:t>files</a:t>
-            </a:r>
-            <a:r>
-              <a:rPr lang="de-AT" dirty="0"/>
-              <a:t> </a:t>
-            </a:r>
-            <a:r>
-              <a:rPr lang="de-AT" dirty="0" err="1"/>
-              <a:t>may</a:t>
-            </a:r>
-            <a:r>
-              <a:rPr lang="de-AT" dirty="0"/>
-              <a:t> </a:t>
-            </a:r>
-            <a:r>
-              <a:rPr lang="de-AT" dirty="0" err="1"/>
-              <a:t>change</a:t>
-            </a:r>
-            <a:r>
-              <a:rPr lang="de-AT" dirty="0"/>
-              <a:t>.</a:t>
-            </a:r>
-          </a:p>
-        </p:txBody>
-      </p:sp>
-    </p:spTree>
-    <p:extLst>
-      <p:ext uri="{BB962C8B-B14F-4D97-AF65-F5344CB8AC3E}">
-        <p14:creationId xmlns:p14="http://schemas.microsoft.com/office/powerpoint/2010/main" val="3736530436"/>
+        <p14:creationId xmlns:p14="http://schemas.microsoft.com/office/powerpoint/2010/main" val="2344979378"/>
       </p:ext>
     </p:extLst>
   </p:cSld>
@@ -8666,12 +9946,12 @@
 <file path=ppt/theme/theme1.xml><?xml version="1.0" encoding="utf-8"?>
 <a:theme xmlns:a="http://schemas.openxmlformats.org/drawingml/2006/main" name="Office">
   <a:themeElements>
-    <a:clrScheme name="Office">
+    <a:clrScheme name="Energy Analysis">
       <a:dk1>
-        <a:sysClr val="windowText" lastClr="000000"/>
+        <a:srgbClr val="2D3436"/>
       </a:dk1>
       <a:lt1>
-        <a:sysClr val="window" lastClr="FFFFFF"/>
+        <a:srgbClr val="F5F6FA"/>
       </a:lt1>
       <a:dk2>
         <a:srgbClr val="0E2841"/>
@@ -8680,13 +9960,13 @@
         <a:srgbClr val="E8E8E8"/>
       </a:lt2>
       <a:accent1>
-        <a:srgbClr val="156082"/>
+        <a:srgbClr val="2C5F7C"/>
       </a:accent1>
       <a:accent2>
-        <a:srgbClr val="E97132"/>
+        <a:srgbClr val="5A9E6F"/>
       </a:accent2>
       <a:accent3>
-        <a:srgbClr val="196B24"/>
+        <a:srgbClr val="8B7355"/>
       </a:accent3>
       <a:accent4>
         <a:srgbClr val="0F9ED5"/>
@@ -8704,110 +9984,16 @@
         <a:srgbClr val="96607D"/>
       </a:folHlink>
     </a:clrScheme>
-    <a:fontScheme name="Office">
+    <a:fontScheme name="Benutzerdefiniert 1">
       <a:majorFont>
-        <a:latin typeface="Aptos Display" panose="02110004020202020204"/>
+        <a:latin typeface="Aptos Regular"/>
         <a:ea typeface=""/>
         <a:cs typeface=""/>
-        <a:font script="Jpan" typeface="游ゴシック Light"/>
-        <a:font script="Hang" typeface="맑은 고딕"/>
-        <a:font script="Hans" typeface="等线 Light"/>
-        <a:font script="Hant" typeface="新細明體"/>
-        <a:font script="Arab" typeface="Times New Roman"/>
-        <a:font script="Hebr" typeface="Times New Roman"/>
-        <a:font script="Thai" typeface="Angsana New"/>
-        <a:font script="Ethi" typeface="Nyala"/>
-        <a:font script="Beng" typeface="Vrinda"/>
-        <a:font script="Gujr" typeface="Shruti"/>
-        <a:font script="Khmr" typeface="MoolBoran"/>
-        <a:font script="Knda" typeface="Tunga"/>
-        <a:font script="Guru" typeface="Raavi"/>
-        <a:font script="Cans" typeface="Euphemia"/>
-        <a:font script="Cher" typeface="Plantagenet Cherokee"/>
-        <a:font script="Yiii" typeface="Microsoft Yi Baiti"/>
-        <a:font script="Tibt" typeface="Microsoft Himalaya"/>
-        <a:font script="Thaa" typeface="MV Boli"/>
-        <a:font script="Deva" typeface="Mangal"/>
-        <a:font script="Telu" typeface="Gautami"/>
-        <a:font script="Taml" typeface="Latha"/>
-        <a:font script="Syrc" typeface="Estrangelo Edessa"/>
-        <a:font script="Orya" typeface="Kalinga"/>
-        <a:font script="Mlym" typeface="Kartika"/>
-        <a:font script="Laoo" typeface="DokChampa"/>
-        <a:font script="Sinh" typeface="Iskoola Pota"/>
-        <a:font script="Mong" typeface="Mongolian Baiti"/>
-        <a:font script="Viet" typeface="Times New Roman"/>
-        <a:font script="Uigh" typeface="Microsoft Uighur"/>
-        <a:font script="Geor" typeface="Sylfaen"/>
-        <a:font script="Armn" typeface="Arial"/>
-        <a:font script="Bugi" typeface="Leelawadee UI"/>
-        <a:font script="Bopo" typeface="Microsoft JhengHei"/>
-        <a:font script="Java" typeface="Javanese Text"/>
-        <a:font script="Lisu" typeface="Segoe UI"/>
-        <a:font script="Mymr" typeface="Myanmar Text"/>
-        <a:font script="Nkoo" typeface="Ebrima"/>
-        <a:font script="Olck" typeface="Nirmala UI"/>
-        <a:font script="Osma" typeface="Ebrima"/>
-        <a:font script="Phag" typeface="Phagspa"/>
-        <a:font script="Syrn" typeface="Estrangelo Edessa"/>
-        <a:font script="Syrj" typeface="Estrangelo Edessa"/>
-        <a:font script="Syre" typeface="Estrangelo Edessa"/>
-        <a:font script="Sora" typeface="Nirmala UI"/>
-        <a:font script="Tale" typeface="Microsoft Tai Le"/>
-        <a:font script="Talu" typeface="Microsoft New Tai Lue"/>
-        <a:font script="Tfng" typeface="Ebrima"/>
       </a:majorFont>
       <a:minorFont>
-        <a:latin typeface="Aptos" panose="02110004020202020204"/>
+        <a:latin typeface="Aptos"/>
         <a:ea typeface=""/>
         <a:cs typeface=""/>
-        <a:font script="Jpan" typeface="游ゴシック"/>
-        <a:font script="Hang" typeface="맑은 고딕"/>
-        <a:font script="Hans" typeface="等线"/>
-        <a:font script="Hant" typeface="新細明體"/>
-        <a:font script="Arab" typeface="Arial"/>
-        <a:font script="Hebr" typeface="Arial"/>
-        <a:font script="Thai" typeface="Cordia New"/>
-        <a:font script="Ethi" typeface="Nyala"/>
-        <a:font script="Beng" typeface="Vrinda"/>
-        <a:font script="Gujr" typeface="Shruti"/>
-        <a:font script="Khmr" typeface="DaunPenh"/>
-        <a:font script="Knda" typeface="Tunga"/>
-        <a:font script="Guru" typeface="Raavi"/>
-        <a:font script="Cans" typeface="Euphemia"/>
-        <a:font script="Cher" typeface="Plantagenet Cherokee"/>
-        <a:font script="Yiii" typeface="Microsoft Yi Baiti"/>
-        <a:font script="Tibt" typeface="Microsoft Himalaya"/>
-        <a:font script="Thaa" typeface="MV Boli"/>
-        <a:font script="Deva" typeface="Mangal"/>
-        <a:font script="Telu" typeface="Gautami"/>
-        <a:font script="Taml" typeface="Latha"/>
-        <a:font script="Syrc" typeface="Estrangelo Edessa"/>
-        <a:font script="Orya" typeface="Kalinga"/>
-        <a:font script="Mlym" typeface="Kartika"/>
-        <a:font script="Laoo" typeface="DokChampa"/>
-        <a:font script="Sinh" typeface="Iskoola Pota"/>
-        <a:font script="Mong" typeface="Mongolian Baiti"/>
-        <a:font script="Viet" typeface="Arial"/>
-        <a:font script="Uigh" typeface="Microsoft Uighur"/>
-        <a:font script="Geor" typeface="Sylfaen"/>
-        <a:font script="Armn" typeface="Arial"/>
-        <a:font script="Bugi" typeface="Leelawadee UI"/>
-        <a:font script="Bopo" typeface="Microsoft JhengHei"/>
-        <a:font script="Java" typeface="Javanese Text"/>
-        <a:font script="Lisu" typeface="Segoe UI"/>
-        <a:font script="Mymr" typeface="Myanmar Text"/>
-        <a:font script="Nkoo" typeface="Ebrima"/>
-        <a:font script="Olck" typeface="Nirmala UI"/>
-        <a:font script="Osma" typeface="Ebrima"/>
-        <a:font script="Phag" typeface="Phagspa"/>
-        <a:font script="Syrn" typeface="Estrangelo Edessa"/>
-        <a:font script="Syrj" typeface="Estrangelo Edessa"/>
-        <a:font script="Syre" typeface="Estrangelo Edessa"/>
-        <a:font script="Sora" typeface="Nirmala UI"/>
-        <a:font script="Tale" typeface="Microsoft Tai Le"/>
-        <a:font script="Talu" typeface="Microsoft New Tai Lue"/>
-        <a:font script="Tfng" typeface="Ebrima"/>
       </a:minorFont>
     </a:fontScheme>
     <a:fmtScheme name="Office">

</xml_diff>